<commit_message>
SSLC r5 addendum: amber box all-steps, motion 5 style, path-to-close §3 wording
</commit_message>
<xml_diff>
--- a/drafts/Exos_SSLC_Board_Offer_Overview_2026-10-12_r5.pptx
+++ b/drafts/Exos_SSLC_Board_Offer_Overview_2026-10-12_r5.pptx
@@ -13666,7 +13666,7 @@
         <p:spPr>
           <a:xfrm>
             <a:off x="4736592" y="3095244"/>
-            <a:ext cx="4133087" cy="923544"/>
+            <a:ext cx="4133087" cy="1024128"/>
           </a:xfrm>
           <a:prstGeom prst="rect">
             <a:avLst/>
@@ -13680,68 +13680,57 @@
           <a:lstStyle/>
           <a:p>
             <a:r>
-              <a:rPr lang="en-US" sz="1000" dirty="0">
-                <a:solidFill>
-                  <a:srgbClr val="FFCC44"/>
-                </a:solidFill>
-                <a:latin typeface="Calibri"/>
-              </a:rPr>
-              <a:t>Step 1: Facility credit ~$351K (Microcosm 50% rent+util, Jul 2024-Aug 2026)</a:t>
-            </a:r>
-          </a:p>
-          <a:p>
-            <a:r>
-              <a:rPr lang="en-US" sz="1000" dirty="0">
-                <a:solidFill>
-                  <a:srgbClr val="FFCC44"/>
-                </a:solidFill>
-                <a:latin typeface="Calibri"/>
-              </a:rPr>
-              <a:t>  + Bookstore capitalized interest $97K = $448K not credited to SSLC holders.</a:t>
-            </a:r>
-          </a:p>
-          <a:p>
-            <a:r>
-              <a:rPr lang="en-US" sz="1000" b="1" dirty="0">
-                <a:solidFill>
-                  <a:srgbClr val="FF0000"/>
-                </a:solidFill>
-                <a:latin typeface="Calibri"/>
-              </a:rPr>
-              <a:t>Net cash at close: ~$1.39M (as booked)  →  ~$1.84M (Step 1 applied).</a:t>
-            </a:r>
-          </a:p>
-          <a:p>
-            <a:r>
-              <a:rPr lang="en-US" sz="1000" dirty="0">
-                <a:solidFill>
-                  <a:srgbClr val="FFCC44"/>
-                </a:solidFill>
-                <a:latin typeface="Calibri"/>
-              </a:rPr>
-              <a:t>Adjusted: Due to Microcosm → ~$100K;  Bookstore note → $223K.</a:t>
-            </a:r>
-          </a:p>
-          <a:p>
-            <a:r>
-              <a:rPr lang="en-US" sz="1000" dirty="0">
-                <a:solidFill>
-                  <a:srgbClr val="FFCC44"/>
-                </a:solidFill>
-                <a:latin typeface="Calibri"/>
-              </a:rPr>
-              <a:t>Paid-in: books $224K (non-Exos);  register basis $461K (Motion 2).</a:t>
-            </a:r>
-          </a:p>
-          <a:p>
-            <a:r>
-              <a:rPr lang="en-US" sz="1000" dirty="0">
+              <a:rPr lang="en-US" sz="950" dirty="0">
                 <a:solidFill>
                   <a:srgbClr val="CCCCCC"/>
                 </a:solidFill>
                 <a:latin typeface="Calibri"/>
               </a:rPr>
-              <a:t>Exos: $790,000 for 18.06% (157,553 shares).</a:t>
+              <a:t>Step 1 (+$448K — facility credit + capitalized interest):</a:t>
+            </a:r>
+          </a:p>
+          <a:p>
+            <a:r>
+              <a:rPr lang="en-US" sz="950" dirty="0">
+                <a:solidFill>
+                  <a:srgbClr val="CCCCCC"/>
+                </a:solidFill>
+                <a:latin typeface="Calibri"/>
+              </a:rPr>
+              <a:t>  Net cash at close ≈ $1.84M  ·  per 1% ≈ $22.4K</a:t>
+            </a:r>
+          </a:p>
+          <a:p>
+            <a:r>
+              <a:rPr lang="en-US" sz="1000" dirty="0" b="1">
+                <a:solidFill>
+                  <a:srgbClr val="FF4444"/>
+                </a:solidFill>
+                <a:latin typeface="Calibri"/>
+              </a:rPr>
+              <a:t>ALL STEPS APPLIED  (Steps 1+2+3, +$1,261,001):</a:t>
+            </a:r>
+          </a:p>
+          <a:p>
+            <a:r>
+              <a:rPr lang="en-US" sz="1100" dirty="0" b="1">
+                <a:solidFill>
+                  <a:srgbClr val="FF4444"/>
+                </a:solidFill>
+                <a:latin typeface="Calibri"/>
+              </a:rPr>
+              <a:t>  Net cash at close ≈ $2.65M  ·  per 1% of SSLC ≈ $32.3K</a:t>
+            </a:r>
+          </a:p>
+          <a:p>
+            <a:r>
+              <a:rPr lang="en-US" sz="950" dirty="0" i="1">
+                <a:solidFill>
+                  <a:srgbClr val="FF8888"/>
+                </a:solidFill>
+                <a:latin typeface="Calibri"/>
+              </a:rPr>
+              <a:t>  ($1.39M as booked → +$1,261K corrections → ≈ $2.65M)</a:t>
             </a:r>
           </a:p>
         </p:txBody>
@@ -16044,9 +16033,9 @@
           <a:p>
             <a:pPr algn="l"/>
             <a:r>
-              <a:rPr sz="1800" b="1" i="0">
-                <a:solidFill>
-                  <a:srgbClr val="FFCC44"/>
+              <a:rPr sz="2200" b="1" i="0">
+                <a:solidFill>
+                  <a:srgbClr val="F26A21"/>
                 </a:solidFill>
                 <a:latin typeface="Calibri"/>
               </a:rPr>
@@ -16079,9 +16068,9 @@
           <a:p>
             <a:pPr algn="l"/>
             <a:r>
-              <a:rPr sz="1100" b="1" i="0" dirty="0">
-                <a:solidFill>
-                  <a:srgbClr val="FFCC44"/>
+              <a:rPr sz="1000" b="1" i="0" dirty="0">
+                <a:solidFill>
+                  <a:srgbClr val="F26A21"/>
                 </a:solidFill>
                 <a:latin typeface="Calibri"/>
               </a:rPr>
@@ -16116,7 +16105,7 @@
             <a:r>
               <a:rPr sz="1000" b="0" i="0" dirty="0">
                 <a:solidFill>
-                  <a:srgbClr val="FFFFFF"/>
+                  <a:srgbClr val="44BB44"/>
                 </a:solidFill>
                 <a:latin typeface="Calibri"/>
               </a:rPr>
@@ -16151,7 +16140,7 @@
             <a:r>
               <a:rPr sz="1000" b="0" i="0" dirty="0">
                 <a:solidFill>
-                  <a:srgbClr val="FFFFFF"/>
+                  <a:srgbClr val="FF6666"/>
                 </a:solidFill>
                 <a:latin typeface="Calibri"/>
               </a:rPr>
@@ -16186,7 +16175,7 @@
             <a:r>
               <a:rPr sz="1000" b="0" i="0" dirty="0">
                 <a:solidFill>
-                  <a:srgbClr val="FFFFFF"/>
+                  <a:srgbClr val="CCCCCC"/>
                 </a:solidFill>
                 <a:latin typeface="Calibri"/>
               </a:rPr>
@@ -16600,7 +16589,7 @@
                   <a:srgbClr val="FFFFFF"/>
                 </a:solidFill>
               </a:rPr>
-              <a:t>Board Votes — Five Motions</a:t>
+              <a:t>Board vote on the offer and §3 exclusivity (90 days + 60-day extension if significant progress)</a:t>
             </a:r>
             <a:endParaRPr lang="en-US" sz="1400" dirty="0"/>
           </a:p>

</xml_diff>

<commit_message>
SSLC r5 QA: fix register table overwrites/ledger values, slide 5 step descriptions, April-30 attribution + band overlap, Conger/Rufer impact columns, earn-out text fit, path-to-close step 1, remove empty WC row
</commit_message>
<xml_diff>
--- a/drafts/Exos_SSLC_Board_Offer_Overview_2026-10-12_r5.pptx
+++ b/drafts/Exos_SSLC_Board_Offer_Overview_2026-10-12_r5.pptx
@@ -3083,7 +3083,7 @@
                   <a:srgbClr val="F26A21"/>
                 </a:solidFill>
               </a:rPr>
-              <a:t>$3.0M/yr</a:t>
+              <a:t>$3M/yr → $150K/yr → $750K</a:t>
             </a:r>
             <a:endParaRPr lang="en-US" sz="900" dirty="0"/>
           </a:p>
@@ -3097,7 +3097,7 @@
                   <a:srgbClr val="F26A21"/>
                 </a:solidFill>
               </a:rPr>
-              <a:t>→$150K/yr</a:t>
+              <a:t/>
             </a:r>
             <a:endParaRPr lang="en-US" sz="900" dirty="0"/>
           </a:p>
@@ -3111,7 +3111,7 @@
                   <a:srgbClr val="F26A21"/>
                 </a:solidFill>
               </a:rPr>
-              <a:t>→$750K total</a:t>
+              <a:t/>
             </a:r>
             <a:endParaRPr lang="en-US" sz="900" dirty="0"/>
           </a:p>
@@ -3179,7 +3179,7 @@
                   <a:srgbClr val="F26A21"/>
                 </a:solidFill>
               </a:rPr>
-              <a:t>$5.0M/yr</a:t>
+              <a:t>$5M/yr → $250K/yr → $1.25M</a:t>
             </a:r>
             <a:endParaRPr lang="en-US" sz="900" dirty="0"/>
           </a:p>
@@ -3193,7 +3193,7 @@
                   <a:srgbClr val="F26A21"/>
                 </a:solidFill>
               </a:rPr>
-              <a:t>→$250K/yr</a:t>
+              <a:t/>
             </a:r>
             <a:endParaRPr lang="en-US" sz="900" dirty="0"/>
           </a:p>
@@ -3207,7 +3207,7 @@
                   <a:srgbClr val="F26A21"/>
                 </a:solidFill>
               </a:rPr>
-              <a:t>→$1.25M total</a:t>
+              <a:t/>
             </a:r>
             <a:endParaRPr lang="en-US" sz="900" dirty="0"/>
           </a:p>
@@ -3275,7 +3275,7 @@
                   <a:srgbClr val="F26A21"/>
                 </a:solidFill>
               </a:rPr>
-              <a:t>$6.0M+/yr</a:t>
+              <a:t>$6M+/yr → $300K/yr cap → $1.5M</a:t>
             </a:r>
             <a:endParaRPr lang="en-US" sz="900" dirty="0"/>
           </a:p>
@@ -3289,7 +3289,7 @@
                   <a:srgbClr val="F26A21"/>
                 </a:solidFill>
               </a:rPr>
-              <a:t>→$300K/yr (cap)</a:t>
+              <a:t/>
             </a:r>
             <a:endParaRPr lang="en-US" sz="900" dirty="0"/>
           </a:p>
@@ -3303,7 +3303,7 @@
                   <a:srgbClr val="F26A21"/>
                 </a:solidFill>
               </a:rPr>
-              <a:t>→$1.5M total</a:t>
+              <a:t/>
             </a:r>
             <a:endParaRPr lang="en-US" sz="900" dirty="0"/>
           </a:p>
@@ -3453,7 +3453,7 @@
                   <a:srgbClr val="CCCCCC"/>
                 </a:solidFill>
               </a:rPr>
-              <a:t>M1  SSLC FY27 rev ≥$5.1M  →$200K</a:t>
+              <a:t>M1  FY27 revenue ≥$5.1M → $200K</a:t>
             </a:r>
             <a:endParaRPr lang="en-US" sz="900" dirty="0"/>
           </a:p>
@@ -3861,7 +3861,7 @@
                   <a:srgbClr val="CCCCCC"/>
                 </a:solidFill>
               </a:rPr>
-              <a:t>M2  Nebula OTV flight tank set delivered &amp; accepted by IM  →$200K</a:t>
+              <a:t>M2  Nebula OTV tank set accepted → $200K</a:t>
             </a:r>
             <a:endParaRPr lang="en-US" sz="900" dirty="0"/>
           </a:p>
@@ -4269,7 +4269,7 @@
                   <a:srgbClr val="CCCCCC"/>
                 </a:solidFill>
               </a:rPr>
-              <a:t>M3  SSLC annual rev ≥$10M  →$250K</a:t>
+              <a:t>M3  Revenue ≥$10M year → $250K</a:t>
             </a:r>
             <a:endParaRPr lang="en-US" sz="900" dirty="0"/>
           </a:p>
@@ -4677,7 +4677,7 @@
                   <a:srgbClr val="CCCCCC"/>
                 </a:solidFill>
               </a:rPr>
-              <a:t>M4  SSLC annual rev ≥$20M  →$250K</a:t>
+              <a:t>M4  Revenue ≥$20M year → $250K</a:t>
             </a:r>
             <a:endParaRPr lang="en-US" sz="900" dirty="0"/>
           </a:p>
@@ -5085,7 +5085,7 @@
                   <a:srgbClr val="CCCCCC"/>
                 </a:solidFill>
               </a:rPr>
-              <a:t>M5  50% reduction in tank build cost</a:t>
+              <a:t>M5  50% build-cost cut → $200K</a:t>
             </a:r>
             <a:endParaRPr lang="en-US" sz="900" dirty="0"/>
           </a:p>
@@ -5099,7 +5099,7 @@
                   <a:srgbClr val="CCCCCC"/>
                 </a:solidFill>
               </a:rPr>
-              <a:t>(dome &amp; build-process automation proven)  →$200K (High)</a:t>
+              <a:t/>
             </a:r>
             <a:endParaRPr lang="en-US" sz="900" dirty="0"/>
           </a:p>
@@ -5535,7 +5535,7 @@
                   <a:srgbClr val="CCCCCC"/>
                 </a:solidFill>
               </a:rPr>
-              <a:t>(adds to ~0.59% EAI up-front)</a:t>
+              <a:t/>
             </a:r>
             <a:endParaRPr lang="en-US" sz="900" dirty="0"/>
           </a:p>
@@ -5999,7 +5999,7 @@
                   <a:srgbClr val="CCCCCC"/>
                 </a:solidFill>
               </a:rPr>
-              <a:t>TOTAL EARN-OUTS  (③ minus ②)</a:t>
+              <a:t>TOTAL EARN-OUTS (③ − ②)</a:t>
             </a:r>
             <a:endParaRPr lang="en-US" sz="900" dirty="0"/>
           </a:p>
@@ -6441,7 +6441,7 @@
         </p:nvSpPr>
         <p:spPr>
           <a:xfrm>
-            <a:off x="320040" y="4343400"/>
+            <a:off x="320040" y="4315968"/>
             <a:ext cx="8503920" cy="411480"/>
           </a:xfrm>
           <a:prstGeom prst="rect">
@@ -6462,7 +6462,7 @@
                 </a:solidFill>
                 <a:latin typeface="Calibri"/>
               </a:rPr>
-              <a:t>How the earn-outs pay SSLC holders:  (1) Cash milestones (M1–M5) pay at trigger event, distributed pro-rata to non-Exos holders.  (2) Revenue sharing (5% of IM tank revenue/yr, FY27–FY31, capped $300K/yr) pays annually against verified SSLC revenue.  (3) Exos stock earn-out issues as EAI units at RTO listing — not before, and only if RTO closes.</a:t>
+              <a:t>How it pays SSLC holders: (1) milestone cash M1–M5 at each trigger; (2) 5% of IM tank revenue every year FY27–FY31 (a $5M year pays $250K; cap $300K/yr); (3) Exos stock at the RTO listing. All on top of cash at close.</a:t>
             </a:r>
           </a:p>
         </p:txBody>
@@ -16589,7 +16589,7 @@
                   <a:srgbClr val="FFFFFF"/>
                 </a:solidFill>
               </a:rPr>
-              <a:t>Board vote on the offer and §3 exclusivity (90 days + 60-day extension if significant progress)</a:t>
+              <a:t>Board Vote: Offer + §3 Exclusivity (90 days + 60-day ext.)</a:t>
             </a:r>
             <a:endParaRPr lang="en-US" sz="1400" dirty="0"/>
           </a:p>
@@ -22195,7 +22195,7 @@
         <p:spPr>
           <a:xfrm>
             <a:off x="256032" y="2286000"/>
-            <a:ext cx="3657600" cy="164592"/>
+            <a:ext cx="2651760" cy="164592"/>
           </a:xfrm>
           <a:prstGeom prst="rect">
             <a:avLst/>
@@ -22228,8 +22228,8 @@
         </p:nvSpPr>
         <p:spPr>
           <a:xfrm>
-            <a:off x="3977639" y="2286000"/>
-            <a:ext cx="5029200" cy="164592"/>
+            <a:off x="2926080" y="2286000"/>
+            <a:ext cx="2011680" cy="164592"/>
           </a:xfrm>
           <a:prstGeom prst="rect">
             <a:avLst/>
@@ -22263,7 +22263,7 @@
         <p:spPr>
           <a:xfrm>
             <a:off x="256032" y="2468880"/>
-            <a:ext cx="3657600" cy="164592"/>
+            <a:ext cx="2651760" cy="164592"/>
           </a:xfrm>
           <a:prstGeom prst="rect">
             <a:avLst/>
@@ -22296,8 +22296,8 @@
         </p:nvSpPr>
         <p:spPr>
           <a:xfrm>
-            <a:off x="3977639" y="2468880"/>
-            <a:ext cx="5029200" cy="164592"/>
+            <a:off x="2926080" y="2468880"/>
+            <a:ext cx="2011680" cy="164592"/>
           </a:xfrm>
           <a:prstGeom prst="rect">
             <a:avLst/>
@@ -22331,7 +22331,7 @@
         <p:spPr>
           <a:xfrm>
             <a:off x="256032" y="2651760"/>
-            <a:ext cx="3657600" cy="164592"/>
+            <a:ext cx="2651760" cy="164592"/>
           </a:xfrm>
           <a:prstGeom prst="rect">
             <a:avLst/>
@@ -22364,8 +22364,8 @@
         </p:nvSpPr>
         <p:spPr>
           <a:xfrm>
-            <a:off x="3977639" y="2651760"/>
-            <a:ext cx="5029200" cy="164592"/>
+            <a:off x="2926080" y="2651760"/>
+            <a:ext cx="2011680" cy="164592"/>
           </a:xfrm>
           <a:prstGeom prst="rect">
             <a:avLst/>
@@ -22520,7 +22520,7 @@
         </p:nvSpPr>
         <p:spPr>
           <a:xfrm>
-            <a:off x="256032" y="3108960"/>
+            <a:off x="256032" y="3172968"/>
             <a:ext cx="8631936" cy="182880"/>
           </a:xfrm>
           <a:prstGeom prst="rect">
@@ -22535,37 +22535,139 @@
           <a:lstStyle/>
           <a:p>
             <a:r>
-              <a:rPr lang="en-US" sz="1100" dirty="0" b="1">
+              <a:rPr lang="en-US" sz="1050" dirty="0" b="1">
                 <a:solidFill>
                   <a:srgbClr val="FFFFFF"/>
                 </a:solidFill>
                 <a:latin typeface="Calibri"/>
               </a:rPr>
-              <a:t>WHAT THIS MEANS FOR SSLC SHAREHOLDERS OUTSIDE THE MICROCOSM/WERTZ GROUP.</a:t>
-            </a:r>
-          </a:p>
+              <a:t>WHAT THIS MEANS FOR SHAREHOLDERS OUTSIDE MICROCOSM/WERTZ: cash at a Jan 15, 2027 close per 1% of SSLC (8,725 sh.)</a:t>
+            </a:r>
+          </a:p>
+          <a:p>
+            <a:r>
+              <a:rPr lang="en-US" sz="1050" dirty="0">
+                <a:solidFill>
+                  <a:srgbClr val="CCCCCC"/>
+                </a:solidFill>
+                <a:latin typeface="Calibri"/>
+              </a:rPr>
+              <a:t/>
+            </a:r>
+          </a:p>
+        </p:txBody>
+      </p:sp>
+      <p:sp>
+        <p:nvSpPr>
+          <p:cNvPr id="66" name="TextBox 65"/>
+          <p:cNvSpPr txBox="1"/>
+          <p:nvPr/>
+        </p:nvSpPr>
+        <p:spPr>
+          <a:xfrm>
+            <a:off x="256032" y="3392424"/>
+            <a:ext cx="3749039" cy="164592"/>
+          </a:xfrm>
+          <a:prstGeom prst="rect">
+            <a:avLst/>
+          </a:prstGeom>
+          <a:noFill/>
+        </p:spPr>
+        <p:txBody>
+          <a:bodyPr wrap="none" anchor="ctr">
+            <a:spAutoFit/>
+          </a:bodyPr>
+          <a:lstStyle/>
           <a:p>
             <a:r>
               <a:rPr lang="en-US" sz="1000" dirty="0">
                 <a:solidFill>
-                  <a:srgbClr val="CCCCCC"/>
-                </a:solidFill>
-                <a:latin typeface="Calibri"/>
-              </a:rPr>
-              <a:t>Cash at a Jan 15, 2027 close for each 1% of SSLC owned (8,725 shares).</a:t>
-            </a:r>
-          </a:p>
-        </p:txBody>
-      </p:sp>
-      <p:sp>
-        <p:nvSpPr>
-          <p:cNvPr id="66" name="TextBox 65"/>
-          <p:cNvSpPr txBox="1"/>
-          <p:nvPr/>
-        </p:nvSpPr>
-        <p:spPr>
-          <a:xfrm>
-            <a:off x="256032" y="3328416"/>
+                  <a:srgbClr val="888888"/>
+                </a:solidFill>
+                <a:latin typeface="Calibri"/>
+              </a:rPr>
+              <a:t>As booked (no corrections applied):</a:t>
+            </a:r>
+          </a:p>
+        </p:txBody>
+      </p:sp>
+      <p:sp>
+        <p:nvSpPr>
+          <p:cNvPr id="67" name="TextBox 66"/>
+          <p:cNvSpPr txBox="1"/>
+          <p:nvPr/>
+        </p:nvSpPr>
+        <p:spPr>
+          <a:xfrm>
+            <a:off x="4114800" y="3392424"/>
+            <a:ext cx="2194560" cy="164592"/>
+          </a:xfrm>
+          <a:prstGeom prst="rect">
+            <a:avLst/>
+          </a:prstGeom>
+          <a:noFill/>
+        </p:spPr>
+        <p:txBody>
+          <a:bodyPr wrap="none" anchor="ctr">
+            <a:spAutoFit/>
+          </a:bodyPr>
+          <a:lstStyle/>
+          <a:p>
+            <a:r>
+              <a:rPr lang="en-US" sz="1000" dirty="0">
+                <a:solidFill>
+                  <a:srgbClr val="888888"/>
+                </a:solidFill>
+                <a:latin typeface="Calibri"/>
+              </a:rPr>
+              <a:t>$1,388,000 / 82 =</a:t>
+            </a:r>
+          </a:p>
+        </p:txBody>
+      </p:sp>
+      <p:sp>
+        <p:nvSpPr>
+          <p:cNvPr id="68" name="TextBox 67"/>
+          <p:cNvSpPr txBox="1"/>
+          <p:nvPr/>
+        </p:nvSpPr>
+        <p:spPr>
+          <a:xfrm>
+            <a:off x="6400800" y="3392424"/>
+            <a:ext cx="2560320" cy="164592"/>
+          </a:xfrm>
+          <a:prstGeom prst="rect">
+            <a:avLst/>
+          </a:prstGeom>
+          <a:noFill/>
+        </p:spPr>
+        <p:txBody>
+          <a:bodyPr wrap="none" anchor="ctr">
+            <a:spAutoFit/>
+          </a:bodyPr>
+          <a:lstStyle/>
+          <a:p>
+            <a:r>
+              <a:rPr lang="en-US" sz="1000" b="1" dirty="0">
+                <a:solidFill>
+                  <a:srgbClr val="888888"/>
+                </a:solidFill>
+                <a:latin typeface="Calibri"/>
+              </a:rPr>
+              <a:t>$16.9K</a:t>
+            </a:r>
+          </a:p>
+        </p:txBody>
+      </p:sp>
+      <p:sp>
+        <p:nvSpPr>
+          <p:cNvPr id="69" name="TextBox 68"/>
+          <p:cNvSpPr txBox="1"/>
+          <p:nvPr/>
+        </p:nvSpPr>
+        <p:spPr>
+          <a:xfrm>
+            <a:off x="256032" y="3579876"/>
             <a:ext cx="3749039" cy="164592"/>
           </a:xfrm>
           <a:prstGeom prst="rect">
@@ -22582,24 +22684,126 @@
             <a:r>
               <a:rPr lang="en-US" sz="1000" dirty="0">
                 <a:solidFill>
+                  <a:srgbClr val="F26A21"/>
+                </a:solidFill>
+                <a:latin typeface="Calibri"/>
+              </a:rPr>
+              <a:t>Step 1 applied (+$448K — facility credit + capitalized interest):</a:t>
+            </a:r>
+          </a:p>
+        </p:txBody>
+      </p:sp>
+      <p:sp>
+        <p:nvSpPr>
+          <p:cNvPr id="70" name="TextBox 69"/>
+          <p:cNvSpPr txBox="1"/>
+          <p:nvPr/>
+        </p:nvSpPr>
+        <p:spPr>
+          <a:xfrm>
+            <a:off x="4114800" y="3579876"/>
+            <a:ext cx="2194560" cy="164592"/>
+          </a:xfrm>
+          <a:prstGeom prst="rect">
+            <a:avLst/>
+          </a:prstGeom>
+          <a:noFill/>
+        </p:spPr>
+        <p:txBody>
+          <a:bodyPr wrap="none" anchor="ctr">
+            <a:spAutoFit/>
+          </a:bodyPr>
+          <a:lstStyle/>
+          <a:p>
+            <a:r>
+              <a:rPr lang="en-US" sz="1000" dirty="0">
+                <a:solidFill>
                   <a:srgbClr val="888888"/>
                 </a:solidFill>
                 <a:latin typeface="Calibri"/>
               </a:rPr>
-              <a:t>As booked (no corrections applied):</a:t>
-            </a:r>
-          </a:p>
-        </p:txBody>
-      </p:sp>
-      <p:sp>
-        <p:nvSpPr>
-          <p:cNvPr id="67" name="TextBox 66"/>
-          <p:cNvSpPr txBox="1"/>
-          <p:nvPr/>
-        </p:nvSpPr>
-        <p:spPr>
-          <a:xfrm>
-            <a:off x="4114800" y="3328416"/>
+              <a:t>$1,836,000 / 82 =</a:t>
+            </a:r>
+          </a:p>
+        </p:txBody>
+      </p:sp>
+      <p:sp>
+        <p:nvSpPr>
+          <p:cNvPr id="71" name="TextBox 70"/>
+          <p:cNvSpPr txBox="1"/>
+          <p:nvPr/>
+        </p:nvSpPr>
+        <p:spPr>
+          <a:xfrm>
+            <a:off x="6400800" y="3579876"/>
+            <a:ext cx="2560320" cy="164592"/>
+          </a:xfrm>
+          <a:prstGeom prst="rect">
+            <a:avLst/>
+          </a:prstGeom>
+          <a:noFill/>
+        </p:spPr>
+        <p:txBody>
+          <a:bodyPr wrap="none" anchor="ctr">
+            <a:spAutoFit/>
+          </a:bodyPr>
+          <a:lstStyle/>
+          <a:p>
+            <a:r>
+              <a:rPr lang="en-US" sz="1000" b="1" dirty="0">
+                <a:solidFill>
+                  <a:srgbClr val="F26A21"/>
+                </a:solidFill>
+                <a:latin typeface="Calibri"/>
+              </a:rPr>
+              <a:t>$22.4K</a:t>
+            </a:r>
+          </a:p>
+        </p:txBody>
+      </p:sp>
+      <p:sp>
+        <p:nvSpPr>
+          <p:cNvPr id="72" name="TextBox 71"/>
+          <p:cNvSpPr txBox="1"/>
+          <p:nvPr/>
+        </p:nvSpPr>
+        <p:spPr>
+          <a:xfrm>
+            <a:off x="256032" y="3767328"/>
+            <a:ext cx="3749039" cy="164592"/>
+          </a:xfrm>
+          <a:prstGeom prst="rect">
+            <a:avLst/>
+          </a:prstGeom>
+          <a:noFill/>
+        </p:spPr>
+        <p:txBody>
+          <a:bodyPr wrap="none" anchor="ctr">
+            <a:spAutoFit/>
+          </a:bodyPr>
+          <a:lstStyle/>
+          <a:p>
+            <a:r>
+              <a:rPr lang="en-US" sz="1000" dirty="0">
+                <a:solidFill>
+                  <a:srgbClr val="F26A21"/>
+                </a:solidFill>
+                <a:latin typeface="Calibri"/>
+              </a:rPr>
+              <a:t>Steps 1+2 (+$967K — + unsupported offsets corrected):</a:t>
+            </a:r>
+          </a:p>
+        </p:txBody>
+      </p:sp>
+      <p:sp>
+        <p:nvSpPr>
+          <p:cNvPr id="73" name="TextBox 72"/>
+          <p:cNvSpPr txBox="1"/>
+          <p:nvPr/>
+        </p:nvSpPr>
+        <p:spPr>
+          <a:xfrm>
+            <a:off x="4114800" y="3767328"/>
             <a:ext cx="2194560" cy="164592"/>
           </a:xfrm>
           <a:prstGeom prst="rect">
@@ -22620,20 +22824,20 @@
                 </a:solidFill>
                 <a:latin typeface="Calibri"/>
               </a:rPr>
-              <a:t>$1,388,000 / 82 =</a:t>
-            </a:r>
-          </a:p>
-        </p:txBody>
-      </p:sp>
-      <p:sp>
-        <p:nvSpPr>
-          <p:cNvPr id="68" name="TextBox 67"/>
-          <p:cNvSpPr txBox="1"/>
-          <p:nvPr/>
-        </p:nvSpPr>
-        <p:spPr>
-          <a:xfrm>
-            <a:off x="6400800" y="3328416"/>
+              <a:t>$2,355,000 / 82 =</a:t>
+            </a:r>
+          </a:p>
+        </p:txBody>
+      </p:sp>
+      <p:sp>
+        <p:nvSpPr>
+          <p:cNvPr id="74" name="TextBox 73"/>
+          <p:cNvSpPr txBox="1"/>
+          <p:nvPr/>
+        </p:nvSpPr>
+        <p:spPr>
+          <a:xfrm>
+            <a:off x="6400800" y="3767328"/>
             <a:ext cx="2560320" cy="164592"/>
           </a:xfrm>
           <a:prstGeom prst="rect">
@@ -22650,282 +22854,78 @@
             <a:r>
               <a:rPr lang="en-US" sz="1000" b="1" dirty="0">
                 <a:solidFill>
+                  <a:srgbClr val="F26A21"/>
+                </a:solidFill>
+                <a:latin typeface="Calibri"/>
+              </a:rPr>
+              <a:t>$28.7K</a:t>
+            </a:r>
+          </a:p>
+        </p:txBody>
+      </p:sp>
+      <p:sp>
+        <p:nvSpPr>
+          <p:cNvPr id="75" name="TextBox 74"/>
+          <p:cNvSpPr txBox="1"/>
+          <p:nvPr/>
+        </p:nvSpPr>
+        <p:spPr>
+          <a:xfrm>
+            <a:off x="256032" y="3954780"/>
+            <a:ext cx="3749039" cy="164592"/>
+          </a:xfrm>
+          <a:prstGeom prst="rect">
+            <a:avLst/>
+          </a:prstGeom>
+          <a:noFill/>
+        </p:spPr>
+        <p:txBody>
+          <a:bodyPr wrap="none" anchor="ctr">
+            <a:spAutoFit/>
+          </a:bodyPr>
+          <a:lstStyle/>
+          <a:p>
+            <a:r>
+              <a:rPr lang="en-US" sz="1000" dirty="0">
+                <a:solidFill>
+                  <a:srgbClr val="44BB44"/>
+                </a:solidFill>
+                <a:latin typeface="Calibri"/>
+              </a:rPr>
+              <a:t>Steps 1+2+3 (+$1,261K — all three corrections applied):</a:t>
+            </a:r>
+          </a:p>
+        </p:txBody>
+      </p:sp>
+      <p:sp>
+        <p:nvSpPr>
+          <p:cNvPr id="76" name="TextBox 75"/>
+          <p:cNvSpPr txBox="1"/>
+          <p:nvPr/>
+        </p:nvSpPr>
+        <p:spPr>
+          <a:xfrm>
+            <a:off x="4114800" y="3954780"/>
+            <a:ext cx="2194560" cy="164592"/>
+          </a:xfrm>
+          <a:prstGeom prst="rect">
+            <a:avLst/>
+          </a:prstGeom>
+          <a:noFill/>
+        </p:spPr>
+        <p:txBody>
+          <a:bodyPr wrap="none" anchor="ctr">
+            <a:spAutoFit/>
+          </a:bodyPr>
+          <a:lstStyle/>
+          <a:p>
+            <a:r>
+              <a:rPr lang="en-US" sz="1000" dirty="0">
+                <a:solidFill>
                   <a:srgbClr val="888888"/>
                 </a:solidFill>
                 <a:latin typeface="Calibri"/>
               </a:rPr>
-              <a:t>$16.9K</a:t>
-            </a:r>
-          </a:p>
-        </p:txBody>
-      </p:sp>
-      <p:sp>
-        <p:nvSpPr>
-          <p:cNvPr id="69" name="TextBox 68"/>
-          <p:cNvSpPr txBox="1"/>
-          <p:nvPr/>
-        </p:nvSpPr>
-        <p:spPr>
-          <a:xfrm>
-            <a:off x="256032" y="3515868"/>
-            <a:ext cx="3749039" cy="164592"/>
-          </a:xfrm>
-          <a:prstGeom prst="rect">
-            <a:avLst/>
-          </a:prstGeom>
-          <a:noFill/>
-        </p:spPr>
-        <p:txBody>
-          <a:bodyPr wrap="none" anchor="ctr">
-            <a:spAutoFit/>
-          </a:bodyPr>
-          <a:lstStyle/>
-          <a:p>
-            <a:r>
-              <a:rPr lang="en-US" sz="1000" dirty="0">
-                <a:solidFill>
-                  <a:srgbClr val="F26A21"/>
-                </a:solidFill>
-                <a:latin typeface="Calibri"/>
-              </a:rPr>
-              <a:t>Step 1 applied (+$448K — facility credit + capitalized interest):</a:t>
-            </a:r>
-          </a:p>
-        </p:txBody>
-      </p:sp>
-      <p:sp>
-        <p:nvSpPr>
-          <p:cNvPr id="70" name="TextBox 69"/>
-          <p:cNvSpPr txBox="1"/>
-          <p:nvPr/>
-        </p:nvSpPr>
-        <p:spPr>
-          <a:xfrm>
-            <a:off x="4114800" y="3515868"/>
-            <a:ext cx="2194560" cy="164592"/>
-          </a:xfrm>
-          <a:prstGeom prst="rect">
-            <a:avLst/>
-          </a:prstGeom>
-          <a:noFill/>
-        </p:spPr>
-        <p:txBody>
-          <a:bodyPr wrap="none" anchor="ctr">
-            <a:spAutoFit/>
-          </a:bodyPr>
-          <a:lstStyle/>
-          <a:p>
-            <a:r>
-              <a:rPr lang="en-US" sz="1000" dirty="0">
-                <a:solidFill>
-                  <a:srgbClr val="888888"/>
-                </a:solidFill>
-                <a:latin typeface="Calibri"/>
-              </a:rPr>
-              <a:t>$1,836,000 / 82 =</a:t>
-            </a:r>
-          </a:p>
-        </p:txBody>
-      </p:sp>
-      <p:sp>
-        <p:nvSpPr>
-          <p:cNvPr id="71" name="TextBox 70"/>
-          <p:cNvSpPr txBox="1"/>
-          <p:nvPr/>
-        </p:nvSpPr>
-        <p:spPr>
-          <a:xfrm>
-            <a:off x="6400800" y="3515868"/>
-            <a:ext cx="2560320" cy="164592"/>
-          </a:xfrm>
-          <a:prstGeom prst="rect">
-            <a:avLst/>
-          </a:prstGeom>
-          <a:noFill/>
-        </p:spPr>
-        <p:txBody>
-          <a:bodyPr wrap="none" anchor="ctr">
-            <a:spAutoFit/>
-          </a:bodyPr>
-          <a:lstStyle/>
-          <a:p>
-            <a:r>
-              <a:rPr lang="en-US" sz="1000" b="1" dirty="0">
-                <a:solidFill>
-                  <a:srgbClr val="F26A21"/>
-                </a:solidFill>
-                <a:latin typeface="Calibri"/>
-              </a:rPr>
-              <a:t>$22.4K</a:t>
-            </a:r>
-          </a:p>
-        </p:txBody>
-      </p:sp>
-      <p:sp>
-        <p:nvSpPr>
-          <p:cNvPr id="72" name="TextBox 71"/>
-          <p:cNvSpPr txBox="1"/>
-          <p:nvPr/>
-        </p:nvSpPr>
-        <p:spPr>
-          <a:xfrm>
-            <a:off x="256032" y="3703320"/>
-            <a:ext cx="3749039" cy="164592"/>
-          </a:xfrm>
-          <a:prstGeom prst="rect">
-            <a:avLst/>
-          </a:prstGeom>
-          <a:noFill/>
-        </p:spPr>
-        <p:txBody>
-          <a:bodyPr wrap="none" anchor="ctr">
-            <a:spAutoFit/>
-          </a:bodyPr>
-          <a:lstStyle/>
-          <a:p>
-            <a:r>
-              <a:rPr lang="en-US" sz="1000" dirty="0">
-                <a:solidFill>
-                  <a:srgbClr val="F26A21"/>
-                </a:solidFill>
-                <a:latin typeface="Calibri"/>
-              </a:rPr>
-              <a:t>Steps 1+2 (+$967K — + unsupported offsets corrected):</a:t>
-            </a:r>
-          </a:p>
-        </p:txBody>
-      </p:sp>
-      <p:sp>
-        <p:nvSpPr>
-          <p:cNvPr id="73" name="TextBox 72"/>
-          <p:cNvSpPr txBox="1"/>
-          <p:nvPr/>
-        </p:nvSpPr>
-        <p:spPr>
-          <a:xfrm>
-            <a:off x="4114800" y="3703320"/>
-            <a:ext cx="2194560" cy="164592"/>
-          </a:xfrm>
-          <a:prstGeom prst="rect">
-            <a:avLst/>
-          </a:prstGeom>
-          <a:noFill/>
-        </p:spPr>
-        <p:txBody>
-          <a:bodyPr wrap="none" anchor="ctr">
-            <a:spAutoFit/>
-          </a:bodyPr>
-          <a:lstStyle/>
-          <a:p>
-            <a:r>
-              <a:rPr lang="en-US" sz="1000" dirty="0">
-                <a:solidFill>
-                  <a:srgbClr val="888888"/>
-                </a:solidFill>
-                <a:latin typeface="Calibri"/>
-              </a:rPr>
-              <a:t>$2,355,000 / 82 =</a:t>
-            </a:r>
-          </a:p>
-        </p:txBody>
-      </p:sp>
-      <p:sp>
-        <p:nvSpPr>
-          <p:cNvPr id="74" name="TextBox 73"/>
-          <p:cNvSpPr txBox="1"/>
-          <p:nvPr/>
-        </p:nvSpPr>
-        <p:spPr>
-          <a:xfrm>
-            <a:off x="6400800" y="3703320"/>
-            <a:ext cx="2560320" cy="164592"/>
-          </a:xfrm>
-          <a:prstGeom prst="rect">
-            <a:avLst/>
-          </a:prstGeom>
-          <a:noFill/>
-        </p:spPr>
-        <p:txBody>
-          <a:bodyPr wrap="none" anchor="ctr">
-            <a:spAutoFit/>
-          </a:bodyPr>
-          <a:lstStyle/>
-          <a:p>
-            <a:r>
-              <a:rPr lang="en-US" sz="1000" b="1" dirty="0">
-                <a:solidFill>
-                  <a:srgbClr val="F26A21"/>
-                </a:solidFill>
-                <a:latin typeface="Calibri"/>
-              </a:rPr>
-              <a:t>$28.7K</a:t>
-            </a:r>
-          </a:p>
-        </p:txBody>
-      </p:sp>
-      <p:sp>
-        <p:nvSpPr>
-          <p:cNvPr id="75" name="TextBox 74"/>
-          <p:cNvSpPr txBox="1"/>
-          <p:nvPr/>
-        </p:nvSpPr>
-        <p:spPr>
-          <a:xfrm>
-            <a:off x="256032" y="3890772"/>
-            <a:ext cx="3749039" cy="164592"/>
-          </a:xfrm>
-          <a:prstGeom prst="rect">
-            <a:avLst/>
-          </a:prstGeom>
-          <a:noFill/>
-        </p:spPr>
-        <p:txBody>
-          <a:bodyPr wrap="none" anchor="ctr">
-            <a:spAutoFit/>
-          </a:bodyPr>
-          <a:lstStyle/>
-          <a:p>
-            <a:r>
-              <a:rPr lang="en-US" sz="1000" dirty="0">
-                <a:solidFill>
-                  <a:srgbClr val="44BB44"/>
-                </a:solidFill>
-                <a:latin typeface="Calibri"/>
-              </a:rPr>
-              <a:t>Steps 1+2+3 (+$1,261K — all three corrections applied):</a:t>
-            </a:r>
-          </a:p>
-        </p:txBody>
-      </p:sp>
-      <p:sp>
-        <p:nvSpPr>
-          <p:cNvPr id="76" name="TextBox 75"/>
-          <p:cNvSpPr txBox="1"/>
-          <p:nvPr/>
-        </p:nvSpPr>
-        <p:spPr>
-          <a:xfrm>
-            <a:off x="4114800" y="3890772"/>
-            <a:ext cx="2194560" cy="164592"/>
-          </a:xfrm>
-          <a:prstGeom prst="rect">
-            <a:avLst/>
-          </a:prstGeom>
-          <a:noFill/>
-        </p:spPr>
-        <p:txBody>
-          <a:bodyPr wrap="none" anchor="ctr">
-            <a:spAutoFit/>
-          </a:bodyPr>
-          <a:lstStyle/>
-          <a:p>
-            <a:r>
-              <a:rPr lang="en-US" sz="1000" dirty="0">
-                <a:solidFill>
-                  <a:srgbClr val="888888"/>
-                </a:solidFill>
-                <a:latin typeface="Calibri"/>
-              </a:rPr>
               <a:t>$2,649,000 / 82 =</a:t>
             </a:r>
           </a:p>
@@ -22939,7 +22939,7 @@
         </p:nvSpPr>
         <p:spPr>
           <a:xfrm>
-            <a:off x="6400800" y="3890772"/>
+            <a:off x="6400800" y="3954780"/>
             <a:ext cx="2560320" cy="164592"/>
           </a:xfrm>
           <a:prstGeom prst="rect">
@@ -22995,6 +22995,108 @@
                 <a:latin typeface="Calibri"/>
               </a:rPr>
               <a:t>S3</a:t>
+            </a:r>
+          </a:p>
+        </p:txBody>
+      </p:sp>
+      <p:sp>
+        <p:nvSpPr>
+          <p:cNvPr id="57" name="TextBox 56"/>
+          <p:cNvSpPr txBox="1"/>
+          <p:nvPr/>
+        </p:nvSpPr>
+        <p:spPr>
+          <a:xfrm>
+            <a:off x="4983480" y="2286000"/>
+            <a:ext cx="3977639" cy="164592"/>
+          </a:xfrm>
+          <a:prstGeom prst="rect">
+            <a:avLst/>
+          </a:prstGeom>
+          <a:noFill/>
+        </p:spPr>
+        <p:txBody>
+          <a:bodyPr wrap="none" anchor="ctr">
+            <a:spAutoFit/>
+          </a:bodyPr>
+          <a:lstStyle/>
+          <a:p>
+            <a:r>
+              <a:rPr lang="en-US" sz="1000" b="0" dirty="0" i="1">
+                <a:solidFill>
+                  <a:srgbClr val="CCCCCC"/>
+                </a:solidFill>
+                <a:latin typeface="Calibri"/>
+              </a:rPr>
+              <a:t>Facility credit + no Bookstore interest: holders recover $448K.</a:t>
+            </a:r>
+          </a:p>
+        </p:txBody>
+      </p:sp>
+      <p:sp>
+        <p:nvSpPr>
+          <p:cNvPr id="59" name="TextBox 58"/>
+          <p:cNvSpPr txBox="1"/>
+          <p:nvPr/>
+        </p:nvSpPr>
+        <p:spPr>
+          <a:xfrm>
+            <a:off x="4983480" y="2468880"/>
+            <a:ext cx="3977639" cy="164592"/>
+          </a:xfrm>
+          <a:prstGeom prst="rect">
+            <a:avLst/>
+          </a:prstGeom>
+          <a:noFill/>
+        </p:spPr>
+        <p:txBody>
+          <a:bodyPr wrap="none" anchor="ctr">
+            <a:spAutoFit/>
+          </a:bodyPr>
+          <a:lstStyle/>
+          <a:p>
+            <a:r>
+              <a:rPr lang="en-US" sz="1000" b="0" dirty="0" i="1">
+                <a:solidFill>
+                  <a:srgbClr val="CCCCCC"/>
+                </a:solidFill>
+                <a:latin typeface="Calibri"/>
+              </a:rPr>
+              <a:t>Also reverse $518K of netting offsets with no invoices.</a:t>
+            </a:r>
+          </a:p>
+        </p:txBody>
+      </p:sp>
+      <p:sp>
+        <p:nvSpPr>
+          <p:cNvPr id="61" name="TextBox 60"/>
+          <p:cNvSpPr txBox="1"/>
+          <p:nvPr/>
+        </p:nvSpPr>
+        <p:spPr>
+          <a:xfrm>
+            <a:off x="4983480" y="2651760"/>
+            <a:ext cx="3977639" cy="164592"/>
+          </a:xfrm>
+          <a:prstGeom prst="rect">
+            <a:avLst/>
+          </a:prstGeom>
+          <a:noFill/>
+        </p:spPr>
+        <p:txBody>
+          <a:bodyPr wrap="none" anchor="ctr">
+            <a:spAutoFit/>
+          </a:bodyPr>
+          <a:lstStyle/>
+          <a:p>
+            <a:r>
+              <a:rPr lang="en-US" sz="1000" b="0" dirty="0" i="1">
+                <a:solidFill>
+                  <a:srgbClr val="CCCCCC"/>
+                </a:solidFill>
+                <a:latin typeface="Calibri"/>
+              </a:rPr>
+              <a:t>Also reverse the undocumented pre-2024 $294K Microcosm loan.</a:t>
             </a:r>
           </a:p>
         </p:txBody>
@@ -23121,13 +23223,13 @@
         <p:spPr>
           <a:xfrm>
             <a:off x="256032" y="1645920"/>
-            <a:ext cx="4206240" cy="155448"/>
+            <a:ext cx="4480560" cy="155448"/>
           </a:xfrm>
           <a:prstGeom prst="rect">
             <a:avLst/>
           </a:prstGeom>
           <a:solidFill>
-            <a:srgbClr val="2D1A00"/>
+            <a:srgbClr val="7A1F1F"/>
           </a:solidFill>
           <a:ln>
             <a:noFill/>
@@ -23164,13 +23266,13 @@
         <p:spPr>
           <a:xfrm>
             <a:off x="256032" y="1481328"/>
-            <a:ext cx="4206240" cy="155448"/>
+            <a:ext cx="4480560" cy="155448"/>
           </a:xfrm>
           <a:prstGeom prst="rect">
             <a:avLst/>
           </a:prstGeom>
           <a:solidFill>
-            <a:srgbClr val="3D0000"/>
+            <a:srgbClr val="7A1F1F"/>
           </a:solidFill>
           <a:ln>
             <a:noFill/>
@@ -23519,8 +23621,7 @@
                 </a:solidFill>
                 <a:latin typeface="Calibri"/>
               </a:rPr>
-              <a:t>⚠  Conger: cert #3 (44,000 sh.) missing from ledger.
-     Only cert #43 (29,000 sh.) shown. Motion 2 corrects both.</a:t>
+              <a:t>⚠  Conger: cert #3 (44,000 sh.) not listed by name on the ledger (folded into 'other'). Motion 2 corrects both.</a:t>
             </a:r>
           </a:p>
         </p:txBody>
@@ -23533,7 +23634,7 @@
         </p:nvSpPr>
         <p:spPr>
           <a:xfrm>
-            <a:off x="256032" y="2834640"/>
+            <a:off x="256032" y="2898648"/>
             <a:ext cx="4206240" cy="201168"/>
           </a:xfrm>
           <a:prstGeom prst="rect">
@@ -23567,7 +23668,7 @@
         </p:nvSpPr>
         <p:spPr>
           <a:xfrm>
-            <a:off x="256032" y="3054096"/>
+            <a:off x="256032" y="3108960"/>
             <a:ext cx="4206240" cy="164592"/>
           </a:xfrm>
           <a:prstGeom prst="rect">
@@ -24618,7 +24719,7 @@
         <p:spPr>
           <a:xfrm>
             <a:off x="256032" y="969264"/>
-            <a:ext cx="1188720" cy="164592"/>
+            <a:ext cx="914400" cy="164592"/>
           </a:xfrm>
           <a:prstGeom prst="rect">
             <a:avLst/>
@@ -24651,7 +24752,147 @@
         </p:nvSpPr>
         <p:spPr>
           <a:xfrm>
-            <a:off x="1508760" y="969264"/>
+            <a:off x="1188720" y="969264"/>
+            <a:ext cx="685800" cy="164592"/>
+          </a:xfrm>
+          <a:prstGeom prst="rect">
+            <a:avLst/>
+          </a:prstGeom>
+          <a:noFill/>
+        </p:spPr>
+        <p:txBody>
+          <a:bodyPr wrap="none">
+            <a:spAutoFit/>
+          </a:bodyPr>
+          <a:lstStyle/>
+          <a:p>
+            <a:pPr algn="r"/>
+            <a:r>
+              <a:rPr lang="en-US" sz="1000" b="1" dirty="0">
+                <a:solidFill>
+                  <a:srgbClr val="F26A21"/>
+                </a:solidFill>
+                <a:latin typeface="Calibri"/>
+              </a:rPr>
+              <a:t>Register</a:t>
+            </a:r>
+          </a:p>
+        </p:txBody>
+      </p:sp>
+      <p:sp>
+        <p:nvSpPr>
+          <p:cNvPr id="98" name="TextBox 97"/>
+          <p:cNvSpPr txBox="1"/>
+          <p:nvPr/>
+        </p:nvSpPr>
+        <p:spPr>
+          <a:xfrm>
+            <a:off x="1901952" y="969264"/>
+            <a:ext cx="594360" cy="164592"/>
+          </a:xfrm>
+          <a:prstGeom prst="rect">
+            <a:avLst/>
+          </a:prstGeom>
+          <a:noFill/>
+        </p:spPr>
+        <p:txBody>
+          <a:bodyPr wrap="none">
+            <a:spAutoFit/>
+          </a:bodyPr>
+          <a:lstStyle/>
+          <a:p>
+            <a:pPr algn="r"/>
+            <a:r>
+              <a:rPr lang="en-US" sz="1000" b="1" dirty="0">
+                <a:solidFill>
+                  <a:srgbClr val="F26A21"/>
+                </a:solidFill>
+                <a:latin typeface="Calibri"/>
+              </a:rPr>
+              <a:t>Reg %</a:t>
+            </a:r>
+          </a:p>
+        </p:txBody>
+      </p:sp>
+      <p:sp>
+        <p:nvSpPr>
+          <p:cNvPr id="99" name="TextBox 98"/>
+          <p:cNvSpPr txBox="1"/>
+          <p:nvPr/>
+        </p:nvSpPr>
+        <p:spPr>
+          <a:xfrm>
+            <a:off x="2523744" y="969264"/>
+            <a:ext cx="685800" cy="164592"/>
+          </a:xfrm>
+          <a:prstGeom prst="rect">
+            <a:avLst/>
+          </a:prstGeom>
+          <a:noFill/>
+        </p:spPr>
+        <p:txBody>
+          <a:bodyPr wrap="none">
+            <a:spAutoFit/>
+          </a:bodyPr>
+          <a:lstStyle/>
+          <a:p>
+            <a:pPr algn="r"/>
+            <a:r>
+              <a:rPr lang="en-US" sz="1000" b="1" dirty="0">
+                <a:solidFill>
+                  <a:srgbClr val="F26A21"/>
+                </a:solidFill>
+                <a:latin typeface="Calibri"/>
+              </a:rPr>
+              <a:t>Ledger</a:t>
+            </a:r>
+          </a:p>
+        </p:txBody>
+      </p:sp>
+      <p:sp>
+        <p:nvSpPr>
+          <p:cNvPr id="100" name="TextBox 99"/>
+          <p:cNvSpPr txBox="1"/>
+          <p:nvPr/>
+        </p:nvSpPr>
+        <p:spPr>
+          <a:xfrm>
+            <a:off x="3236976" y="969264"/>
+            <a:ext cx="594360" cy="164592"/>
+          </a:xfrm>
+          <a:prstGeom prst="rect">
+            <a:avLst/>
+          </a:prstGeom>
+          <a:noFill/>
+        </p:spPr>
+        <p:txBody>
+          <a:bodyPr wrap="none">
+            <a:spAutoFit/>
+          </a:bodyPr>
+          <a:lstStyle/>
+          <a:p>
+            <a:pPr algn="r"/>
+            <a:r>
+              <a:rPr lang="en-US" sz="1000" b="1" dirty="0">
+                <a:solidFill>
+                  <a:srgbClr val="F26A21"/>
+                </a:solidFill>
+                <a:latin typeface="Calibri"/>
+              </a:rPr>
+              <a:t>Ldgr %</a:t>
+            </a:r>
+          </a:p>
+        </p:txBody>
+      </p:sp>
+      <p:sp>
+        <p:nvSpPr>
+          <p:cNvPr id="101" name="TextBox 100"/>
+          <p:cNvSpPr txBox="1"/>
+          <p:nvPr/>
+        </p:nvSpPr>
+        <p:spPr>
+          <a:xfrm>
+            <a:off x="3858768" y="969264"/>
             <a:ext cx="822960" cy="164592"/>
           </a:xfrm>
           <a:prstGeom prst="rect">
@@ -24665,142 +24906,7 @@
           </a:bodyPr>
           <a:lstStyle/>
           <a:p>
-            <a:r>
-              <a:rPr lang="en-US" sz="1000" b="1" dirty="0">
-                <a:solidFill>
-                  <a:srgbClr val="F26A21"/>
-                </a:solidFill>
-                <a:latin typeface="Calibri"/>
-              </a:rPr>
-              <a:t>Register</a:t>
-            </a:r>
-          </a:p>
-        </p:txBody>
-      </p:sp>
-      <p:sp>
-        <p:nvSpPr>
-          <p:cNvPr id="98" name="TextBox 97"/>
-          <p:cNvSpPr txBox="1"/>
-          <p:nvPr/>
-        </p:nvSpPr>
-        <p:spPr>
-          <a:xfrm>
-            <a:off x="2377440" y="969264"/>
-            <a:ext cx="594360" cy="164592"/>
-          </a:xfrm>
-          <a:prstGeom prst="rect">
-            <a:avLst/>
-          </a:prstGeom>
-          <a:noFill/>
-        </p:spPr>
-        <p:txBody>
-          <a:bodyPr wrap="none">
-            <a:spAutoFit/>
-          </a:bodyPr>
-          <a:lstStyle/>
-          <a:p>
-            <a:r>
-              <a:rPr lang="en-US" sz="1000" b="1" dirty="0">
-                <a:solidFill>
-                  <a:srgbClr val="F26A21"/>
-                </a:solidFill>
-                <a:latin typeface="Calibri"/>
-              </a:rPr>
-              <a:t>Reg %</a:t>
-            </a:r>
-          </a:p>
-        </p:txBody>
-      </p:sp>
-      <p:sp>
-        <p:nvSpPr>
-          <p:cNvPr id="99" name="TextBox 98"/>
-          <p:cNvSpPr txBox="1"/>
-          <p:nvPr/>
-        </p:nvSpPr>
-        <p:spPr>
-          <a:xfrm>
-            <a:off x="3017520" y="969264"/>
-            <a:ext cx="731520" cy="164592"/>
-          </a:xfrm>
-          <a:prstGeom prst="rect">
-            <a:avLst/>
-          </a:prstGeom>
-          <a:noFill/>
-        </p:spPr>
-        <p:txBody>
-          <a:bodyPr wrap="none">
-            <a:spAutoFit/>
-          </a:bodyPr>
-          <a:lstStyle/>
-          <a:p>
-            <a:r>
-              <a:rPr lang="en-US" sz="1000" b="1" dirty="0">
-                <a:solidFill>
-                  <a:srgbClr val="F26A21"/>
-                </a:solidFill>
-                <a:latin typeface="Calibri"/>
-              </a:rPr>
-              <a:t>Ledger</a:t>
-            </a:r>
-          </a:p>
-        </p:txBody>
-      </p:sp>
-      <p:sp>
-        <p:nvSpPr>
-          <p:cNvPr id="100" name="TextBox 99"/>
-          <p:cNvSpPr txBox="1"/>
-          <p:nvPr/>
-        </p:nvSpPr>
-        <p:spPr>
-          <a:xfrm>
-            <a:off x="3794760" y="969264"/>
-            <a:ext cx="502920" cy="164592"/>
-          </a:xfrm>
-          <a:prstGeom prst="rect">
-            <a:avLst/>
-          </a:prstGeom>
-          <a:noFill/>
-        </p:spPr>
-        <p:txBody>
-          <a:bodyPr wrap="none">
-            <a:spAutoFit/>
-          </a:bodyPr>
-          <a:lstStyle/>
-          <a:p>
-            <a:r>
-              <a:rPr lang="en-US" sz="1000" b="1" dirty="0">
-                <a:solidFill>
-                  <a:srgbClr val="F26A21"/>
-                </a:solidFill>
-                <a:latin typeface="Calibri"/>
-              </a:rPr>
-              <a:t>Led %</a:t>
-            </a:r>
-          </a:p>
-        </p:txBody>
-      </p:sp>
-      <p:sp>
-        <p:nvSpPr>
-          <p:cNvPr id="101" name="TextBox 100"/>
-          <p:cNvSpPr txBox="1"/>
-          <p:nvPr/>
-        </p:nvSpPr>
-        <p:spPr>
-          <a:xfrm>
-            <a:off x="4343400" y="969264"/>
-            <a:ext cx="594360" cy="164592"/>
-          </a:xfrm>
-          <a:prstGeom prst="rect">
-            <a:avLst/>
-          </a:prstGeom>
-          <a:noFill/>
-        </p:spPr>
-        <p:txBody>
-          <a:bodyPr wrap="none">
-            <a:spAutoFit/>
-          </a:bodyPr>
-          <a:lstStyle/>
-          <a:p>
+            <a:pPr algn="r"/>
             <a:r>
               <a:rPr lang="en-US" sz="1000" b="1" dirty="0">
                 <a:solidFill>
@@ -24866,7 +24972,7 @@
         <p:spPr>
           <a:xfrm>
             <a:off x="256032" y="1152144"/>
-            <a:ext cx="1188720" cy="155448"/>
+            <a:ext cx="914400" cy="155448"/>
           </a:xfrm>
           <a:prstGeom prst="rect">
             <a:avLst/>
@@ -24899,7 +25005,147 @@
         </p:nvSpPr>
         <p:spPr>
           <a:xfrm>
-            <a:off x="1508760" y="1152144"/>
+            <a:off x="1188720" y="1152144"/>
+            <a:ext cx="685800" cy="155448"/>
+          </a:xfrm>
+          <a:prstGeom prst="rect">
+            <a:avLst/>
+          </a:prstGeom>
+          <a:noFill/>
+        </p:spPr>
+        <p:txBody>
+          <a:bodyPr wrap="none">
+            <a:spAutoFit/>
+          </a:bodyPr>
+          <a:lstStyle/>
+          <a:p>
+            <a:pPr algn="r"/>
+            <a:r>
+              <a:rPr lang="en-US" sz="1000" dirty="0">
+                <a:solidFill>
+                  <a:srgbClr val="CCCCCC"/>
+                </a:solidFill>
+                <a:latin typeface="Calibri"/>
+              </a:rPr>
+              <a:t>280,000</a:t>
+            </a:r>
+          </a:p>
+        </p:txBody>
+      </p:sp>
+      <p:sp>
+        <p:nvSpPr>
+          <p:cNvPr id="105" name="TextBox 104"/>
+          <p:cNvSpPr txBox="1"/>
+          <p:nvPr/>
+        </p:nvSpPr>
+        <p:spPr>
+          <a:xfrm>
+            <a:off x="1901952" y="1152144"/>
+            <a:ext cx="594360" cy="155448"/>
+          </a:xfrm>
+          <a:prstGeom prst="rect">
+            <a:avLst/>
+          </a:prstGeom>
+          <a:noFill/>
+        </p:spPr>
+        <p:txBody>
+          <a:bodyPr wrap="none">
+            <a:spAutoFit/>
+          </a:bodyPr>
+          <a:lstStyle/>
+          <a:p>
+            <a:pPr algn="r"/>
+            <a:r>
+              <a:rPr lang="en-US" sz="1000" dirty="0">
+                <a:solidFill>
+                  <a:srgbClr val="CCCCCC"/>
+                </a:solidFill>
+                <a:latin typeface="Calibri"/>
+              </a:rPr>
+              <a:t>32.09%</a:t>
+            </a:r>
+          </a:p>
+        </p:txBody>
+      </p:sp>
+      <p:sp>
+        <p:nvSpPr>
+          <p:cNvPr id="106" name="TextBox 105"/>
+          <p:cNvSpPr txBox="1"/>
+          <p:nvPr/>
+        </p:nvSpPr>
+        <p:spPr>
+          <a:xfrm>
+            <a:off x="2523744" y="1152144"/>
+            <a:ext cx="685800" cy="155448"/>
+          </a:xfrm>
+          <a:prstGeom prst="rect">
+            <a:avLst/>
+          </a:prstGeom>
+          <a:noFill/>
+        </p:spPr>
+        <p:txBody>
+          <a:bodyPr wrap="none">
+            <a:spAutoFit/>
+          </a:bodyPr>
+          <a:lstStyle/>
+          <a:p>
+            <a:pPr algn="r"/>
+            <a:r>
+              <a:rPr lang="en-US" sz="1000" dirty="0">
+                <a:solidFill>
+                  <a:srgbClr val="CCCCCC"/>
+                </a:solidFill>
+                <a:latin typeface="Calibri"/>
+              </a:rPr>
+              <a:t>280,000</a:t>
+            </a:r>
+          </a:p>
+        </p:txBody>
+      </p:sp>
+      <p:sp>
+        <p:nvSpPr>
+          <p:cNvPr id="107" name="TextBox 106"/>
+          <p:cNvSpPr txBox="1"/>
+          <p:nvPr/>
+        </p:nvSpPr>
+        <p:spPr>
+          <a:xfrm>
+            <a:off x="3236976" y="1152144"/>
+            <a:ext cx="594360" cy="155448"/>
+          </a:xfrm>
+          <a:prstGeom prst="rect">
+            <a:avLst/>
+          </a:prstGeom>
+          <a:noFill/>
+        </p:spPr>
+        <p:txBody>
+          <a:bodyPr wrap="none">
+            <a:spAutoFit/>
+          </a:bodyPr>
+          <a:lstStyle/>
+          <a:p>
+            <a:pPr algn="r"/>
+            <a:r>
+              <a:rPr lang="en-US" sz="1000" dirty="0">
+                <a:solidFill>
+                  <a:srgbClr val="CCCCCC"/>
+                </a:solidFill>
+                <a:latin typeface="Calibri"/>
+              </a:rPr>
+              <a:t>33.02%</a:t>
+            </a:r>
+          </a:p>
+        </p:txBody>
+      </p:sp>
+      <p:sp>
+        <p:nvSpPr>
+          <p:cNvPr id="108" name="TextBox 107"/>
+          <p:cNvSpPr txBox="1"/>
+          <p:nvPr/>
+        </p:nvSpPr>
+        <p:spPr>
+          <a:xfrm>
+            <a:off x="3858768" y="1152144"/>
             <a:ext cx="822960" cy="155448"/>
           </a:xfrm>
           <a:prstGeom prst="rect">
@@ -24913,6 +25159,7 @@
           </a:bodyPr>
           <a:lstStyle/>
           <a:p>
+            <a:pPr algn="r"/>
             <a:r>
               <a:rPr lang="en-US" sz="1000" dirty="0">
                 <a:solidFill>
@@ -24920,20 +25167,89 @@
                 </a:solidFill>
                 <a:latin typeface="Calibri"/>
               </a:rPr>
-              <a:t>280,000</a:t>
-            </a:r>
-          </a:p>
-        </p:txBody>
-      </p:sp>
-      <p:sp>
-        <p:nvSpPr>
-          <p:cNvPr id="105" name="TextBox 104"/>
-          <p:cNvSpPr txBox="1"/>
-          <p:nvPr/>
-        </p:nvSpPr>
-        <p:spPr>
-          <a:xfrm>
-            <a:off x="2377440" y="1152144"/>
+              <a:t>0</a:t>
+            </a:r>
+          </a:p>
+        </p:txBody>
+      </p:sp>
+      <p:sp>
+        <p:nvSpPr>
+          <p:cNvPr id="109" name="TextBox 108"/>
+          <p:cNvSpPr txBox="1"/>
+          <p:nvPr/>
+        </p:nvSpPr>
+        <p:spPr>
+          <a:xfrm>
+            <a:off x="256032" y="1316736"/>
+            <a:ext cx="914400" cy="155448"/>
+          </a:xfrm>
+          <a:prstGeom prst="rect">
+            <a:avLst/>
+          </a:prstGeom>
+          <a:noFill/>
+        </p:spPr>
+        <p:txBody>
+          <a:bodyPr wrap="none">
+            <a:spAutoFit/>
+          </a:bodyPr>
+          <a:lstStyle/>
+          <a:p>
+            <a:r>
+              <a:rPr lang="en-US" sz="1000" dirty="0">
+                <a:solidFill>
+                  <a:srgbClr val="CCCCCC"/>
+                </a:solidFill>
+                <a:latin typeface="Calibri"/>
+              </a:rPr>
+              <a:t>Wertz family</a:t>
+            </a:r>
+          </a:p>
+        </p:txBody>
+      </p:sp>
+      <p:sp>
+        <p:nvSpPr>
+          <p:cNvPr id="110" name="TextBox 109"/>
+          <p:cNvSpPr txBox="1"/>
+          <p:nvPr/>
+        </p:nvSpPr>
+        <p:spPr>
+          <a:xfrm>
+            <a:off x="1188720" y="1316736"/>
+            <a:ext cx="685800" cy="155448"/>
+          </a:xfrm>
+          <a:prstGeom prst="rect">
+            <a:avLst/>
+          </a:prstGeom>
+          <a:noFill/>
+        </p:spPr>
+        <p:txBody>
+          <a:bodyPr wrap="none">
+            <a:spAutoFit/>
+          </a:bodyPr>
+          <a:lstStyle/>
+          <a:p>
+            <a:pPr algn="r"/>
+            <a:r>
+              <a:rPr lang="en-US" sz="1000" dirty="0">
+                <a:solidFill>
+                  <a:srgbClr val="CCCCCC"/>
+                </a:solidFill>
+                <a:latin typeface="Calibri"/>
+              </a:rPr>
+              <a:t>103,000</a:t>
+            </a:r>
+          </a:p>
+        </p:txBody>
+      </p:sp>
+      <p:sp>
+        <p:nvSpPr>
+          <p:cNvPr id="111" name="TextBox 110"/>
+          <p:cNvSpPr txBox="1"/>
+          <p:nvPr/>
+        </p:nvSpPr>
+        <p:spPr>
+          <a:xfrm>
+            <a:off x="1901952" y="1316736"/>
             <a:ext cx="594360" cy="155448"/>
           </a:xfrm>
           <a:prstGeom prst="rect">
@@ -24947,6 +25263,7 @@
           </a:bodyPr>
           <a:lstStyle/>
           <a:p>
+            <a:pPr algn="r"/>
             <a:r>
               <a:rPr lang="en-US" sz="1000" dirty="0">
                 <a:solidFill>
@@ -24954,21 +25271,21 @@
                 </a:solidFill>
                 <a:latin typeface="Calibri"/>
               </a:rPr>
-              <a:t>32.09%</a:t>
-            </a:r>
-          </a:p>
-        </p:txBody>
-      </p:sp>
-      <p:sp>
-        <p:nvSpPr>
-          <p:cNvPr id="106" name="TextBox 105"/>
-          <p:cNvSpPr txBox="1"/>
-          <p:nvPr/>
-        </p:nvSpPr>
-        <p:spPr>
-          <a:xfrm>
-            <a:off x="3017520" y="1152144"/>
-            <a:ext cx="731520" cy="155448"/>
+              <a:t>11.80%</a:t>
+            </a:r>
+          </a:p>
+        </p:txBody>
+      </p:sp>
+      <p:sp>
+        <p:nvSpPr>
+          <p:cNvPr id="112" name="TextBox 111"/>
+          <p:cNvSpPr txBox="1"/>
+          <p:nvPr/>
+        </p:nvSpPr>
+        <p:spPr>
+          <a:xfrm>
+            <a:off x="2523744" y="1316736"/>
+            <a:ext cx="685800" cy="155448"/>
           </a:xfrm>
           <a:prstGeom prst="rect">
             <a:avLst/>
@@ -24981,6 +25298,7 @@
           </a:bodyPr>
           <a:lstStyle/>
           <a:p>
+            <a:pPr algn="r"/>
             <a:r>
               <a:rPr lang="en-US" sz="1000" dirty="0">
                 <a:solidFill>
@@ -24988,21 +25306,21 @@
                 </a:solidFill>
                 <a:latin typeface="Calibri"/>
               </a:rPr>
-              <a:t>280,000</a:t>
-            </a:r>
-          </a:p>
-        </p:txBody>
-      </p:sp>
-      <p:sp>
-        <p:nvSpPr>
-          <p:cNvPr id="107" name="TextBox 106"/>
-          <p:cNvSpPr txBox="1"/>
-          <p:nvPr/>
-        </p:nvSpPr>
-        <p:spPr>
-          <a:xfrm>
-            <a:off x="3794760" y="1152144"/>
-            <a:ext cx="502920" cy="155448"/>
+              <a:t>103,000</a:t>
+            </a:r>
+          </a:p>
+        </p:txBody>
+      </p:sp>
+      <p:sp>
+        <p:nvSpPr>
+          <p:cNvPr id="113" name="TextBox 112"/>
+          <p:cNvSpPr txBox="1"/>
+          <p:nvPr/>
+        </p:nvSpPr>
+        <p:spPr>
+          <a:xfrm>
+            <a:off x="3236976" y="1316736"/>
+            <a:ext cx="594360" cy="155448"/>
           </a:xfrm>
           <a:prstGeom prst="rect">
             <a:avLst/>
@@ -25015,6 +25333,7 @@
           </a:bodyPr>
           <a:lstStyle/>
           <a:p>
+            <a:pPr algn="r"/>
             <a:r>
               <a:rPr lang="en-US" sz="1000" dirty="0">
                 <a:solidFill>
@@ -25022,20 +25341,124 @@
                 </a:solidFill>
                 <a:latin typeface="Calibri"/>
               </a:rPr>
-              <a:t>33.02%</a:t>
-            </a:r>
-          </a:p>
-        </p:txBody>
-      </p:sp>
-      <p:sp>
-        <p:nvSpPr>
-          <p:cNvPr id="108" name="TextBox 107"/>
-          <p:cNvSpPr txBox="1"/>
-          <p:nvPr/>
-        </p:nvSpPr>
-        <p:spPr>
-          <a:xfrm>
-            <a:off x="4343400" y="1152144"/>
+              <a:t>12.15%</a:t>
+            </a:r>
+          </a:p>
+        </p:txBody>
+      </p:sp>
+      <p:sp>
+        <p:nvSpPr>
+          <p:cNvPr id="114" name="TextBox 113"/>
+          <p:cNvSpPr txBox="1"/>
+          <p:nvPr/>
+        </p:nvSpPr>
+        <p:spPr>
+          <a:xfrm>
+            <a:off x="3858768" y="1316736"/>
+            <a:ext cx="822960" cy="155448"/>
+          </a:xfrm>
+          <a:prstGeom prst="rect">
+            <a:avLst/>
+          </a:prstGeom>
+          <a:noFill/>
+        </p:spPr>
+        <p:txBody>
+          <a:bodyPr wrap="none">
+            <a:spAutoFit/>
+          </a:bodyPr>
+          <a:lstStyle/>
+          <a:p>
+            <a:pPr algn="r"/>
+            <a:r>
+              <a:rPr lang="en-US" sz="1000" dirty="0">
+                <a:solidFill>
+                  <a:srgbClr val="CCCCCC"/>
+                </a:solidFill>
+                <a:latin typeface="Calibri"/>
+              </a:rPr>
+              <a:t>0</a:t>
+            </a:r>
+          </a:p>
+        </p:txBody>
+      </p:sp>
+      <p:sp>
+        <p:nvSpPr>
+          <p:cNvPr id="115" name="TextBox 114"/>
+          <p:cNvSpPr txBox="1"/>
+          <p:nvPr/>
+        </p:nvSpPr>
+        <p:spPr>
+          <a:xfrm>
+            <a:off x="256032" y="1481328"/>
+            <a:ext cx="914400" cy="155448"/>
+          </a:xfrm>
+          <a:prstGeom prst="rect">
+            <a:avLst/>
+          </a:prstGeom>
+          <a:noFill/>
+        </p:spPr>
+        <p:txBody>
+          <a:bodyPr wrap="none">
+            <a:spAutoFit/>
+          </a:bodyPr>
+          <a:lstStyle/>
+          <a:p>
+            <a:r>
+              <a:rPr lang="en-US" sz="1000" dirty="0" b="1">
+                <a:solidFill>
+                  <a:srgbClr val="FFFFFF"/>
+                </a:solidFill>
+                <a:latin typeface="Calibri"/>
+              </a:rPr>
+              <a:t>Exos</a:t>
+            </a:r>
+          </a:p>
+        </p:txBody>
+      </p:sp>
+      <p:sp>
+        <p:nvSpPr>
+          <p:cNvPr id="116" name="TextBox 115"/>
+          <p:cNvSpPr txBox="1"/>
+          <p:nvPr/>
+        </p:nvSpPr>
+        <p:spPr>
+          <a:xfrm>
+            <a:off x="1188720" y="1481328"/>
+            <a:ext cx="685800" cy="155448"/>
+          </a:xfrm>
+          <a:prstGeom prst="rect">
+            <a:avLst/>
+          </a:prstGeom>
+          <a:noFill/>
+        </p:spPr>
+        <p:txBody>
+          <a:bodyPr wrap="none">
+            <a:spAutoFit/>
+          </a:bodyPr>
+          <a:lstStyle/>
+          <a:p>
+            <a:pPr algn="r"/>
+            <a:r>
+              <a:rPr lang="en-US" sz="1000" dirty="0" b="1">
+                <a:solidFill>
+                  <a:srgbClr val="FFFFFF"/>
+                </a:solidFill>
+                <a:latin typeface="Calibri"/>
+              </a:rPr>
+              <a:t>157,553</a:t>
+            </a:r>
+          </a:p>
+        </p:txBody>
+      </p:sp>
+      <p:sp>
+        <p:nvSpPr>
+          <p:cNvPr id="117" name="TextBox 116"/>
+          <p:cNvSpPr txBox="1"/>
+          <p:nvPr/>
+        </p:nvSpPr>
+        <p:spPr>
+          <a:xfrm>
+            <a:off x="1901952" y="1481328"/>
             <a:ext cx="594360" cy="155448"/>
           </a:xfrm>
           <a:prstGeom prst="rect">
@@ -25049,6 +25472,355 @@
           </a:bodyPr>
           <a:lstStyle/>
           <a:p>
+            <a:pPr algn="r"/>
+            <a:r>
+              <a:rPr lang="en-US" sz="1000" dirty="0" b="1">
+                <a:solidFill>
+                  <a:srgbClr val="FFFFFF"/>
+                </a:solidFill>
+                <a:latin typeface="Calibri"/>
+              </a:rPr>
+              <a:t>18.06%</a:t>
+            </a:r>
+          </a:p>
+        </p:txBody>
+      </p:sp>
+      <p:sp>
+        <p:nvSpPr>
+          <p:cNvPr id="118" name="TextBox 117"/>
+          <p:cNvSpPr txBox="1"/>
+          <p:nvPr/>
+        </p:nvSpPr>
+        <p:spPr>
+          <a:xfrm>
+            <a:off x="2523744" y="1481328"/>
+            <a:ext cx="685800" cy="155448"/>
+          </a:xfrm>
+          <a:prstGeom prst="rect">
+            <a:avLst/>
+          </a:prstGeom>
+          <a:noFill/>
+        </p:spPr>
+        <p:txBody>
+          <a:bodyPr wrap="none">
+            <a:spAutoFit/>
+          </a:bodyPr>
+          <a:lstStyle/>
+          <a:p>
+            <a:pPr algn="r"/>
+            <a:r>
+              <a:rPr lang="en-US" sz="1000" dirty="0" b="1">
+                <a:solidFill>
+                  <a:srgbClr val="FFFFFF"/>
+                </a:solidFill>
+                <a:latin typeface="Calibri"/>
+              </a:rPr>
+              <a:t>132,972</a:t>
+            </a:r>
+          </a:p>
+        </p:txBody>
+      </p:sp>
+      <p:sp>
+        <p:nvSpPr>
+          <p:cNvPr id="119" name="TextBox 118"/>
+          <p:cNvSpPr txBox="1"/>
+          <p:nvPr/>
+        </p:nvSpPr>
+        <p:spPr>
+          <a:xfrm>
+            <a:off x="3236976" y="1481328"/>
+            <a:ext cx="594360" cy="155448"/>
+          </a:xfrm>
+          <a:prstGeom prst="rect">
+            <a:avLst/>
+          </a:prstGeom>
+          <a:noFill/>
+        </p:spPr>
+        <p:txBody>
+          <a:bodyPr wrap="none">
+            <a:spAutoFit/>
+          </a:bodyPr>
+          <a:lstStyle/>
+          <a:p>
+            <a:pPr algn="r"/>
+            <a:r>
+              <a:rPr lang="en-US" sz="1000" dirty="0" b="1">
+                <a:solidFill>
+                  <a:srgbClr val="FFFFFF"/>
+                </a:solidFill>
+                <a:latin typeface="Calibri"/>
+              </a:rPr>
+              <a:t>15.68%</a:t>
+            </a:r>
+          </a:p>
+        </p:txBody>
+      </p:sp>
+      <p:sp>
+        <p:nvSpPr>
+          <p:cNvPr id="120" name="TextBox 119"/>
+          <p:cNvSpPr txBox="1"/>
+          <p:nvPr/>
+        </p:nvSpPr>
+        <p:spPr>
+          <a:xfrm>
+            <a:off x="3858768" y="1481328"/>
+            <a:ext cx="822960" cy="155448"/>
+          </a:xfrm>
+          <a:prstGeom prst="rect">
+            <a:avLst/>
+          </a:prstGeom>
+          <a:noFill/>
+        </p:spPr>
+        <p:txBody>
+          <a:bodyPr wrap="none">
+            <a:spAutoFit/>
+          </a:bodyPr>
+          <a:lstStyle/>
+          <a:p>
+            <a:pPr algn="r"/>
+            <a:r>
+              <a:rPr lang="en-US" sz="1000" dirty="0" b="1">
+                <a:solidFill>
+                  <a:srgbClr val="FFFFFF"/>
+                </a:solidFill>
+                <a:latin typeface="Calibri"/>
+              </a:rPr>
+              <a:t>-24,581</a:t>
+            </a:r>
+          </a:p>
+        </p:txBody>
+      </p:sp>
+      <p:sp>
+        <p:nvSpPr>
+          <p:cNvPr id="121" name="TextBox 120"/>
+          <p:cNvSpPr txBox="1"/>
+          <p:nvPr/>
+        </p:nvSpPr>
+        <p:spPr>
+          <a:xfrm>
+            <a:off x="256032" y="1645920"/>
+            <a:ext cx="914400" cy="155448"/>
+          </a:xfrm>
+          <a:prstGeom prst="rect">
+            <a:avLst/>
+          </a:prstGeom>
+          <a:noFill/>
+        </p:spPr>
+        <p:txBody>
+          <a:bodyPr wrap="none">
+            <a:spAutoFit/>
+          </a:bodyPr>
+          <a:lstStyle/>
+          <a:p>
+            <a:r>
+              <a:rPr lang="en-US" sz="1000" dirty="0" b="1">
+                <a:solidFill>
+                  <a:srgbClr val="FFFFFF"/>
+                </a:solidFill>
+                <a:latin typeface="Calibri"/>
+              </a:rPr>
+              <a:t>Conger</a:t>
+            </a:r>
+          </a:p>
+        </p:txBody>
+      </p:sp>
+      <p:sp>
+        <p:nvSpPr>
+          <p:cNvPr id="122" name="TextBox 121"/>
+          <p:cNvSpPr txBox="1"/>
+          <p:nvPr/>
+        </p:nvSpPr>
+        <p:spPr>
+          <a:xfrm>
+            <a:off x="1188720" y="1645920"/>
+            <a:ext cx="685800" cy="155448"/>
+          </a:xfrm>
+          <a:prstGeom prst="rect">
+            <a:avLst/>
+          </a:prstGeom>
+          <a:noFill/>
+        </p:spPr>
+        <p:txBody>
+          <a:bodyPr wrap="none">
+            <a:spAutoFit/>
+          </a:bodyPr>
+          <a:lstStyle/>
+          <a:p>
+            <a:pPr algn="r"/>
+            <a:r>
+              <a:rPr lang="en-US" sz="1000" dirty="0" b="1">
+                <a:solidFill>
+                  <a:srgbClr val="FFFFFF"/>
+                </a:solidFill>
+                <a:latin typeface="Calibri"/>
+              </a:rPr>
+              <a:t>73,000</a:t>
+            </a:r>
+          </a:p>
+        </p:txBody>
+      </p:sp>
+      <p:sp>
+        <p:nvSpPr>
+          <p:cNvPr id="123" name="TextBox 122"/>
+          <p:cNvSpPr txBox="1"/>
+          <p:nvPr/>
+        </p:nvSpPr>
+        <p:spPr>
+          <a:xfrm>
+            <a:off x="1901952" y="1645920"/>
+            <a:ext cx="594360" cy="155448"/>
+          </a:xfrm>
+          <a:prstGeom prst="rect">
+            <a:avLst/>
+          </a:prstGeom>
+          <a:noFill/>
+        </p:spPr>
+        <p:txBody>
+          <a:bodyPr wrap="none">
+            <a:spAutoFit/>
+          </a:bodyPr>
+          <a:lstStyle/>
+          <a:p>
+            <a:pPr algn="r"/>
+            <a:r>
+              <a:rPr lang="en-US" sz="1000" dirty="0" b="1">
+                <a:solidFill>
+                  <a:srgbClr val="FFFFFF"/>
+                </a:solidFill>
+                <a:latin typeface="Calibri"/>
+              </a:rPr>
+              <a:t> 8.37%</a:t>
+            </a:r>
+          </a:p>
+        </p:txBody>
+      </p:sp>
+      <p:sp>
+        <p:nvSpPr>
+          <p:cNvPr id="124" name="TextBox 123"/>
+          <p:cNvSpPr txBox="1"/>
+          <p:nvPr/>
+        </p:nvSpPr>
+        <p:spPr>
+          <a:xfrm>
+            <a:off x="2523744" y="1645920"/>
+            <a:ext cx="685800" cy="155448"/>
+          </a:xfrm>
+          <a:prstGeom prst="rect">
+            <a:avLst/>
+          </a:prstGeom>
+          <a:noFill/>
+        </p:spPr>
+        <p:txBody>
+          <a:bodyPr wrap="none">
+            <a:spAutoFit/>
+          </a:bodyPr>
+          <a:lstStyle/>
+          <a:p>
+            <a:pPr algn="r"/>
+            <a:r>
+              <a:rPr lang="en-US" sz="1000" dirty="0" b="1">
+                <a:solidFill>
+                  <a:srgbClr val="FFFFFF"/>
+                </a:solidFill>
+                <a:latin typeface="Calibri"/>
+              </a:rPr>
+              <a:t>29,000</a:t>
+            </a:r>
+          </a:p>
+        </p:txBody>
+      </p:sp>
+      <p:sp>
+        <p:nvSpPr>
+          <p:cNvPr id="125" name="TextBox 124"/>
+          <p:cNvSpPr txBox="1"/>
+          <p:nvPr/>
+        </p:nvSpPr>
+        <p:spPr>
+          <a:xfrm>
+            <a:off x="3236976" y="1645920"/>
+            <a:ext cx="594360" cy="155448"/>
+          </a:xfrm>
+          <a:prstGeom prst="rect">
+            <a:avLst/>
+          </a:prstGeom>
+          <a:noFill/>
+        </p:spPr>
+        <p:txBody>
+          <a:bodyPr wrap="none">
+            <a:spAutoFit/>
+          </a:bodyPr>
+          <a:lstStyle/>
+          <a:p>
+            <a:pPr algn="r"/>
+            <a:r>
+              <a:rPr lang="en-US" sz="1000" dirty="0" b="1">
+                <a:solidFill>
+                  <a:srgbClr val="FFFFFF"/>
+                </a:solidFill>
+                <a:latin typeface="Calibri"/>
+              </a:rPr>
+              <a:t> 3.42%</a:t>
+            </a:r>
+          </a:p>
+        </p:txBody>
+      </p:sp>
+      <p:sp>
+        <p:nvSpPr>
+          <p:cNvPr id="126" name="TextBox 125"/>
+          <p:cNvSpPr txBox="1"/>
+          <p:nvPr/>
+        </p:nvSpPr>
+        <p:spPr>
+          <a:xfrm>
+            <a:off x="3858768" y="1645920"/>
+            <a:ext cx="822960" cy="155448"/>
+          </a:xfrm>
+          <a:prstGeom prst="rect">
+            <a:avLst/>
+          </a:prstGeom>
+          <a:noFill/>
+        </p:spPr>
+        <p:txBody>
+          <a:bodyPr wrap="none">
+            <a:spAutoFit/>
+          </a:bodyPr>
+          <a:lstStyle/>
+          <a:p>
+            <a:pPr algn="r"/>
+            <a:r>
+              <a:rPr lang="en-US" sz="1000" dirty="0" b="1">
+                <a:solidFill>
+                  <a:srgbClr val="FFFFFF"/>
+                </a:solidFill>
+                <a:latin typeface="Calibri"/>
+              </a:rPr>
+              <a:t>-44,000</a:t>
+            </a:r>
+          </a:p>
+        </p:txBody>
+      </p:sp>
+      <p:sp>
+        <p:nvSpPr>
+          <p:cNvPr id="127" name="TextBox 126"/>
+          <p:cNvSpPr txBox="1"/>
+          <p:nvPr/>
+        </p:nvSpPr>
+        <p:spPr>
+          <a:xfrm>
+            <a:off x="256032" y="1810512"/>
+            <a:ext cx="914400" cy="155448"/>
+          </a:xfrm>
+          <a:prstGeom prst="rect">
+            <a:avLst/>
+          </a:prstGeom>
+          <a:noFill/>
+        </p:spPr>
+        <p:txBody>
+          <a:bodyPr wrap="none">
+            <a:spAutoFit/>
+          </a:bodyPr>
+          <a:lstStyle/>
+          <a:p>
             <a:r>
               <a:rPr lang="en-US" sz="1000" dirty="0">
                 <a:solidFill>
@@ -25056,21 +25828,21 @@
                 </a:solidFill>
                 <a:latin typeface="Calibri"/>
               </a:rPr>
-              <a:t>   0</a:t>
-            </a:r>
-          </a:p>
-        </p:txBody>
-      </p:sp>
-      <p:sp>
-        <p:nvSpPr>
-          <p:cNvPr id="109" name="TextBox 108"/>
-          <p:cNvSpPr txBox="1"/>
-          <p:nvPr/>
-        </p:nvSpPr>
-        <p:spPr>
-          <a:xfrm>
-            <a:off x="256032" y="1316736"/>
-            <a:ext cx="1188720" cy="155448"/>
+              <a:t>Rufer</a:t>
+            </a:r>
+          </a:p>
+        </p:txBody>
+      </p:sp>
+      <p:sp>
+        <p:nvSpPr>
+          <p:cNvPr id="128" name="TextBox 127"/>
+          <p:cNvSpPr txBox="1"/>
+          <p:nvPr/>
+        </p:nvSpPr>
+        <p:spPr>
+          <a:xfrm>
+            <a:off x="1188720" y="1810512"/>
+            <a:ext cx="685800" cy="155448"/>
           </a:xfrm>
           <a:prstGeom prst="rect">
             <a:avLst/>
@@ -25083,6 +25855,7 @@
           </a:bodyPr>
           <a:lstStyle/>
           <a:p>
+            <a:pPr algn="r"/>
             <a:r>
               <a:rPr lang="en-US" sz="1000" dirty="0">
                 <a:solidFill>
@@ -25090,20 +25863,125 @@
                 </a:solidFill>
                 <a:latin typeface="Calibri"/>
               </a:rPr>
-              <a:t>Wertz family</a:t>
-            </a:r>
-          </a:p>
-        </p:txBody>
-      </p:sp>
-      <p:sp>
-        <p:nvSpPr>
-          <p:cNvPr id="110" name="TextBox 109"/>
-          <p:cNvSpPr txBox="1"/>
-          <p:nvPr/>
-        </p:nvSpPr>
-        <p:spPr>
-          <a:xfrm>
-            <a:off x="1508760" y="1316736"/>
+              <a:t>91,000</a:t>
+            </a:r>
+          </a:p>
+        </p:txBody>
+      </p:sp>
+      <p:sp>
+        <p:nvSpPr>
+          <p:cNvPr id="129" name="TextBox 128"/>
+          <p:cNvSpPr txBox="1"/>
+          <p:nvPr/>
+        </p:nvSpPr>
+        <p:spPr>
+          <a:xfrm>
+            <a:off x="1901952" y="1810512"/>
+            <a:ext cx="594360" cy="155448"/>
+          </a:xfrm>
+          <a:prstGeom prst="rect">
+            <a:avLst/>
+          </a:prstGeom>
+          <a:noFill/>
+        </p:spPr>
+        <p:txBody>
+          <a:bodyPr wrap="none">
+            <a:spAutoFit/>
+          </a:bodyPr>
+          <a:lstStyle/>
+          <a:p>
+            <a:pPr algn="r"/>
+            <a:r>
+              <a:rPr lang="en-US" sz="1000" dirty="0">
+                <a:solidFill>
+                  <a:srgbClr val="CCCCCC"/>
+                </a:solidFill>
+                <a:latin typeface="Calibri"/>
+              </a:rPr>
+              <a:t>10.43%</a:t>
+            </a:r>
+          </a:p>
+        </p:txBody>
+      </p:sp>
+      <p:sp>
+        <p:nvSpPr>
+          <p:cNvPr id="130" name="TextBox 129"/>
+          <p:cNvSpPr txBox="1"/>
+          <p:nvPr/>
+        </p:nvSpPr>
+        <p:spPr>
+          <a:xfrm>
+            <a:off x="2523744" y="1810512"/>
+            <a:ext cx="685800" cy="155448"/>
+          </a:xfrm>
+          <a:prstGeom prst="rect">
+            <a:avLst/>
+          </a:prstGeom>
+          <a:noFill/>
+        </p:spPr>
+        <p:txBody>
+          <a:bodyPr wrap="none">
+            <a:spAutoFit/>
+          </a:bodyPr>
+          <a:lstStyle/>
+          <a:p>
+            <a:pPr algn="r"/>
+            <a:r>
+              <a:rPr lang="en-US" sz="1000" dirty="0">
+                <a:solidFill>
+                  <a:srgbClr val="CCCCCC"/>
+                </a:solidFill>
+                <a:latin typeface="Calibri"/>
+              </a:rPr>
+              <a:t>91,000</a:t>
+            </a:r>
+          </a:p>
+        </p:txBody>
+      </p:sp>
+      <p:sp>
+        <p:nvSpPr>
+          <p:cNvPr id="131" name="TextBox 130"/>
+          <p:cNvSpPr txBox="1"/>
+          <p:nvPr/>
+        </p:nvSpPr>
+        <p:spPr>
+          <a:xfrm>
+            <a:off x="3236976" y="1810512"/>
+            <a:ext cx="594360" cy="155448"/>
+          </a:xfrm>
+          <a:prstGeom prst="rect">
+            <a:avLst/>
+          </a:prstGeom>
+          <a:noFill/>
+        </p:spPr>
+        <p:txBody>
+          <a:bodyPr wrap="none">
+            <a:spAutoFit/>
+          </a:bodyPr>
+          <a:lstStyle/>
+          <a:p>
+            <a:pPr algn="r"/>
+            <a:r>
+              <a:rPr lang="en-US" sz="1000" dirty="0">
+                <a:solidFill>
+                  <a:srgbClr val="CCCCCC"/>
+                </a:solidFill>
+                <a:latin typeface="Calibri"/>
+              </a:rPr>
+              <a:t>10.73%</a:t>
+            </a:r>
+          </a:p>
+        </p:txBody>
+      </p:sp>
+      <p:sp>
+        <p:nvSpPr>
+          <p:cNvPr id="132" name="TextBox 131"/>
+          <p:cNvSpPr txBox="1"/>
+          <p:nvPr/>
+        </p:nvSpPr>
+        <p:spPr>
+          <a:xfrm>
+            <a:off x="3858768" y="1810512"/>
             <a:ext cx="822960" cy="155448"/>
           </a:xfrm>
           <a:prstGeom prst="rect">
@@ -25117,6 +25995,7 @@
           </a:bodyPr>
           <a:lstStyle/>
           <a:p>
+            <a:pPr algn="r"/>
             <a:r>
               <a:rPr lang="en-US" sz="1000" dirty="0">
                 <a:solidFill>
@@ -25124,20 +26003,89 @@
                 </a:solidFill>
                 <a:latin typeface="Calibri"/>
               </a:rPr>
-              <a:t>103,000</a:t>
-            </a:r>
-          </a:p>
-        </p:txBody>
-      </p:sp>
-      <p:sp>
-        <p:nvSpPr>
-          <p:cNvPr id="111" name="TextBox 110"/>
-          <p:cNvSpPr txBox="1"/>
-          <p:nvPr/>
-        </p:nvSpPr>
-        <p:spPr>
-          <a:xfrm>
-            <a:off x="2377440" y="1316736"/>
+              <a:t>0</a:t>
+            </a:r>
+          </a:p>
+        </p:txBody>
+      </p:sp>
+      <p:sp>
+        <p:nvSpPr>
+          <p:cNvPr id="133" name="TextBox 132"/>
+          <p:cNvSpPr txBox="1"/>
+          <p:nvPr/>
+        </p:nvSpPr>
+        <p:spPr>
+          <a:xfrm>
+            <a:off x="256032" y="1975104"/>
+            <a:ext cx="914400" cy="155448"/>
+          </a:xfrm>
+          <a:prstGeom prst="rect">
+            <a:avLst/>
+          </a:prstGeom>
+          <a:noFill/>
+        </p:spPr>
+        <p:txBody>
+          <a:bodyPr wrap="none">
+            <a:spAutoFit/>
+          </a:bodyPr>
+          <a:lstStyle/>
+          <a:p>
+            <a:r>
+              <a:rPr lang="en-US" sz="1000" dirty="0">
+                <a:solidFill>
+                  <a:srgbClr val="CCCCCC"/>
+                </a:solidFill>
+                <a:latin typeface="Calibri"/>
+              </a:rPr>
+              <a:t>Other</a:t>
+            </a:r>
+          </a:p>
+        </p:txBody>
+      </p:sp>
+      <p:sp>
+        <p:nvSpPr>
+          <p:cNvPr id="134" name="TextBox 133"/>
+          <p:cNvSpPr txBox="1"/>
+          <p:nvPr/>
+        </p:nvSpPr>
+        <p:spPr>
+          <a:xfrm>
+            <a:off x="1188720" y="1975104"/>
+            <a:ext cx="685800" cy="155448"/>
+          </a:xfrm>
+          <a:prstGeom prst="rect">
+            <a:avLst/>
+          </a:prstGeom>
+          <a:noFill/>
+        </p:spPr>
+        <p:txBody>
+          <a:bodyPr wrap="none">
+            <a:spAutoFit/>
+          </a:bodyPr>
+          <a:lstStyle/>
+          <a:p>
+            <a:pPr algn="r"/>
+            <a:r>
+              <a:rPr lang="en-US" sz="1000" dirty="0">
+                <a:solidFill>
+                  <a:srgbClr val="CCCCCC"/>
+                </a:solidFill>
+                <a:latin typeface="Calibri"/>
+              </a:rPr>
+              <a:t>167,972</a:t>
+            </a:r>
+          </a:p>
+        </p:txBody>
+      </p:sp>
+      <p:sp>
+        <p:nvSpPr>
+          <p:cNvPr id="135" name="TextBox 134"/>
+          <p:cNvSpPr txBox="1"/>
+          <p:nvPr/>
+        </p:nvSpPr>
+        <p:spPr>
+          <a:xfrm>
+            <a:off x="1901952" y="1975104"/>
             <a:ext cx="594360" cy="155448"/>
           </a:xfrm>
           <a:prstGeom prst="rect">
@@ -25151,6 +26099,7 @@
           </a:bodyPr>
           <a:lstStyle/>
           <a:p>
+            <a:pPr algn="r"/>
             <a:r>
               <a:rPr lang="en-US" sz="1000" dirty="0">
                 <a:solidFill>
@@ -25158,21 +26107,21 @@
                 </a:solidFill>
                 <a:latin typeface="Calibri"/>
               </a:rPr>
-              <a:t>11.80%</a:t>
-            </a:r>
-          </a:p>
-        </p:txBody>
-      </p:sp>
-      <p:sp>
-        <p:nvSpPr>
-          <p:cNvPr id="112" name="TextBox 111"/>
-          <p:cNvSpPr txBox="1"/>
-          <p:nvPr/>
-        </p:nvSpPr>
-        <p:spPr>
-          <a:xfrm>
-            <a:off x="3017520" y="1316736"/>
-            <a:ext cx="731520" cy="155448"/>
+              <a:t>19.25%</a:t>
+            </a:r>
+          </a:p>
+        </p:txBody>
+      </p:sp>
+      <p:sp>
+        <p:nvSpPr>
+          <p:cNvPr id="136" name="TextBox 135"/>
+          <p:cNvSpPr txBox="1"/>
+          <p:nvPr/>
+        </p:nvSpPr>
+        <p:spPr>
+          <a:xfrm>
+            <a:off x="2523744" y="1975104"/>
+            <a:ext cx="685800" cy="155448"/>
           </a:xfrm>
           <a:prstGeom prst="rect">
             <a:avLst/>
@@ -25185,6 +26134,7 @@
           </a:bodyPr>
           <a:lstStyle/>
           <a:p>
+            <a:pPr algn="r"/>
             <a:r>
               <a:rPr lang="en-US" sz="1000" dirty="0">
                 <a:solidFill>
@@ -25192,21 +26142,21 @@
                 </a:solidFill>
                 <a:latin typeface="Calibri"/>
               </a:rPr>
-              <a:t>~103,000</a:t>
-            </a:r>
-          </a:p>
-        </p:txBody>
-      </p:sp>
-      <p:sp>
-        <p:nvSpPr>
-          <p:cNvPr id="113" name="TextBox 112"/>
-          <p:cNvSpPr txBox="1"/>
-          <p:nvPr/>
-        </p:nvSpPr>
-        <p:spPr>
-          <a:xfrm>
-            <a:off x="3794760" y="1316736"/>
-            <a:ext cx="502920" cy="155448"/>
+              <a:t>211,972</a:t>
+            </a:r>
+          </a:p>
+        </p:txBody>
+      </p:sp>
+      <p:sp>
+        <p:nvSpPr>
+          <p:cNvPr id="137" name="TextBox 136"/>
+          <p:cNvSpPr txBox="1"/>
+          <p:nvPr/>
+        </p:nvSpPr>
+        <p:spPr>
+          <a:xfrm>
+            <a:off x="3236976" y="1975104"/>
+            <a:ext cx="594360" cy="155448"/>
           </a:xfrm>
           <a:prstGeom prst="rect">
             <a:avLst/>
@@ -25219,6 +26169,7 @@
           </a:bodyPr>
           <a:lstStyle/>
           <a:p>
+            <a:pPr algn="r"/>
             <a:r>
               <a:rPr lang="en-US" sz="1000" dirty="0">
                 <a:solidFill>
@@ -25226,20 +26177,124 @@
                 </a:solidFill>
                 <a:latin typeface="Calibri"/>
               </a:rPr>
-              <a:t>~12.15%</a:t>
-            </a:r>
-          </a:p>
-        </p:txBody>
-      </p:sp>
-      <p:sp>
-        <p:nvSpPr>
-          <p:cNvPr id="114" name="TextBox 113"/>
-          <p:cNvSpPr txBox="1"/>
-          <p:nvPr/>
-        </p:nvSpPr>
-        <p:spPr>
-          <a:xfrm>
-            <a:off x="4343400" y="1316736"/>
+              <a:t>25.00%</a:t>
+            </a:r>
+          </a:p>
+        </p:txBody>
+      </p:sp>
+      <p:sp>
+        <p:nvSpPr>
+          <p:cNvPr id="138" name="TextBox 137"/>
+          <p:cNvSpPr txBox="1"/>
+          <p:nvPr/>
+        </p:nvSpPr>
+        <p:spPr>
+          <a:xfrm>
+            <a:off x="3858768" y="1975104"/>
+            <a:ext cx="822960" cy="155448"/>
+          </a:xfrm>
+          <a:prstGeom prst="rect">
+            <a:avLst/>
+          </a:prstGeom>
+          <a:noFill/>
+        </p:spPr>
+        <p:txBody>
+          <a:bodyPr wrap="none">
+            <a:spAutoFit/>
+          </a:bodyPr>
+          <a:lstStyle/>
+          <a:p>
+            <a:pPr algn="r"/>
+            <a:r>
+              <a:rPr lang="en-US" sz="1000" dirty="0">
+                <a:solidFill>
+                  <a:srgbClr val="CCCCCC"/>
+                </a:solidFill>
+                <a:latin typeface="Calibri"/>
+              </a:rPr>
+              <a:t>+44,000</a:t>
+            </a:r>
+          </a:p>
+        </p:txBody>
+      </p:sp>
+      <p:sp>
+        <p:nvSpPr>
+          <p:cNvPr id="139" name="TextBox 138"/>
+          <p:cNvSpPr txBox="1"/>
+          <p:nvPr/>
+        </p:nvSpPr>
+        <p:spPr>
+          <a:xfrm>
+            <a:off x="256032" y="2176272"/>
+            <a:ext cx="914400" cy="155448"/>
+          </a:xfrm>
+          <a:prstGeom prst="rect">
+            <a:avLst/>
+          </a:prstGeom>
+          <a:noFill/>
+        </p:spPr>
+        <p:txBody>
+          <a:bodyPr wrap="none">
+            <a:spAutoFit/>
+          </a:bodyPr>
+          <a:lstStyle/>
+          <a:p>
+            <a:r>
+              <a:rPr lang="en-US" sz="1000" b="1" dirty="0">
+                <a:solidFill>
+                  <a:srgbClr val="FFFFFF"/>
+                </a:solidFill>
+                <a:latin typeface="Calibri"/>
+              </a:rPr>
+              <a:t>TOTAL</a:t>
+            </a:r>
+          </a:p>
+        </p:txBody>
+      </p:sp>
+      <p:sp>
+        <p:nvSpPr>
+          <p:cNvPr id="140" name="TextBox 139"/>
+          <p:cNvSpPr txBox="1"/>
+          <p:nvPr/>
+        </p:nvSpPr>
+        <p:spPr>
+          <a:xfrm>
+            <a:off x="1188720" y="2176272"/>
+            <a:ext cx="685800" cy="155448"/>
+          </a:xfrm>
+          <a:prstGeom prst="rect">
+            <a:avLst/>
+          </a:prstGeom>
+          <a:noFill/>
+        </p:spPr>
+        <p:txBody>
+          <a:bodyPr wrap="none">
+            <a:spAutoFit/>
+          </a:bodyPr>
+          <a:lstStyle/>
+          <a:p>
+            <a:pPr algn="r"/>
+            <a:r>
+              <a:rPr lang="en-US" sz="1000" b="1" dirty="0">
+                <a:solidFill>
+                  <a:srgbClr val="FFFFFF"/>
+                </a:solidFill>
+                <a:latin typeface="Calibri"/>
+              </a:rPr>
+              <a:t>872,525</a:t>
+            </a:r>
+          </a:p>
+        </p:txBody>
+      </p:sp>
+      <p:sp>
+        <p:nvSpPr>
+          <p:cNvPr id="141" name="TextBox 140"/>
+          <p:cNvSpPr txBox="1"/>
+          <p:nvPr/>
+        </p:nvSpPr>
+        <p:spPr>
+          <a:xfrm>
+            <a:off x="1901952" y="2176272"/>
             <a:ext cx="594360" cy="155448"/>
           </a:xfrm>
           <a:prstGeom prst="rect">
@@ -25253,28 +26308,29 @@
           </a:bodyPr>
           <a:lstStyle/>
           <a:p>
-            <a:r>
-              <a:rPr lang="en-US" sz="1000" dirty="0">
-                <a:solidFill>
-                  <a:srgbClr val="CCCCCC"/>
-                </a:solidFill>
-                <a:latin typeface="Calibri"/>
-              </a:rPr>
-              <a:t>   —</a:t>
-            </a:r>
-          </a:p>
-        </p:txBody>
-      </p:sp>
-      <p:sp>
-        <p:nvSpPr>
-          <p:cNvPr id="115" name="TextBox 114"/>
-          <p:cNvSpPr txBox="1"/>
-          <p:nvPr/>
-        </p:nvSpPr>
-        <p:spPr>
-          <a:xfrm>
-            <a:off x="256032" y="1481328"/>
-            <a:ext cx="1188720" cy="155448"/>
+            <a:pPr algn="r"/>
+            <a:r>
+              <a:rPr lang="en-US" sz="1000" b="1" dirty="0">
+                <a:solidFill>
+                  <a:srgbClr val="FFFFFF"/>
+                </a:solidFill>
+                <a:latin typeface="Calibri"/>
+              </a:rPr>
+              <a:t>100.0%</a:t>
+            </a:r>
+          </a:p>
+        </p:txBody>
+      </p:sp>
+      <p:sp>
+        <p:nvSpPr>
+          <p:cNvPr id="142" name="TextBox 141"/>
+          <p:cNvSpPr txBox="1"/>
+          <p:nvPr/>
+        </p:nvSpPr>
+        <p:spPr>
+          <a:xfrm>
+            <a:off x="2523744" y="2176272"/>
+            <a:ext cx="685800" cy="155448"/>
           </a:xfrm>
           <a:prstGeom prst="rect">
             <a:avLst/>
@@ -25287,27 +26343,63 @@
           </a:bodyPr>
           <a:lstStyle/>
           <a:p>
-            <a:r>
-              <a:rPr lang="en-US" sz="1000" dirty="0">
-                <a:solidFill>
-                  <a:srgbClr val="DD4444"/>
-                </a:solidFill>
-                <a:latin typeface="Calibri"/>
-              </a:rPr>
-              <a:t>Exos</a:t>
-            </a:r>
-          </a:p>
-        </p:txBody>
-      </p:sp>
-      <p:sp>
-        <p:nvSpPr>
-          <p:cNvPr id="116" name="TextBox 115"/>
-          <p:cNvSpPr txBox="1"/>
-          <p:nvPr/>
-        </p:nvSpPr>
-        <p:spPr>
-          <a:xfrm>
-            <a:off x="1508760" y="1481328"/>
+            <a:pPr algn="r"/>
+            <a:r>
+              <a:rPr lang="en-US" sz="1000" b="1" dirty="0">
+                <a:solidFill>
+                  <a:srgbClr val="FFFFFF"/>
+                </a:solidFill>
+                <a:latin typeface="Calibri"/>
+              </a:rPr>
+              <a:t>847,944</a:t>
+            </a:r>
+          </a:p>
+        </p:txBody>
+      </p:sp>
+      <p:sp>
+        <p:nvSpPr>
+          <p:cNvPr id="143" name="TextBox 142"/>
+          <p:cNvSpPr txBox="1"/>
+          <p:nvPr/>
+        </p:nvSpPr>
+        <p:spPr>
+          <a:xfrm>
+            <a:off x="3236976" y="2176272"/>
+            <a:ext cx="594360" cy="155448"/>
+          </a:xfrm>
+          <a:prstGeom prst="rect">
+            <a:avLst/>
+          </a:prstGeom>
+          <a:noFill/>
+        </p:spPr>
+        <p:txBody>
+          <a:bodyPr wrap="none">
+            <a:spAutoFit/>
+          </a:bodyPr>
+          <a:lstStyle/>
+          <a:p>
+            <a:pPr algn="r"/>
+            <a:r>
+              <a:rPr lang="en-US" sz="1000" b="1" dirty="0">
+                <a:solidFill>
+                  <a:srgbClr val="FFFFFF"/>
+                </a:solidFill>
+                <a:latin typeface="Calibri"/>
+              </a:rPr>
+              <a:t>100.0%</a:t>
+            </a:r>
+          </a:p>
+        </p:txBody>
+      </p:sp>
+      <p:sp>
+        <p:nvSpPr>
+          <p:cNvPr id="144" name="TextBox 143"/>
+          <p:cNvSpPr txBox="1"/>
+          <p:nvPr/>
+        </p:nvSpPr>
+        <p:spPr>
+          <a:xfrm>
+            <a:off x="3858768" y="2176272"/>
             <a:ext cx="822960" cy="155448"/>
           </a:xfrm>
           <a:prstGeom prst="rect">
@@ -25321,958 +26413,7 @@
           </a:bodyPr>
           <a:lstStyle/>
           <a:p>
-            <a:r>
-              <a:rPr lang="en-US" sz="1000" dirty="0">
-                <a:solidFill>
-                  <a:srgbClr val="DD4444"/>
-                </a:solidFill>
-                <a:latin typeface="Calibri"/>
-              </a:rPr>
-              <a:t>157,553</a:t>
-            </a:r>
-          </a:p>
-        </p:txBody>
-      </p:sp>
-      <p:sp>
-        <p:nvSpPr>
-          <p:cNvPr id="117" name="TextBox 116"/>
-          <p:cNvSpPr txBox="1"/>
-          <p:nvPr/>
-        </p:nvSpPr>
-        <p:spPr>
-          <a:xfrm>
-            <a:off x="2377440" y="1481328"/>
-            <a:ext cx="594360" cy="155448"/>
-          </a:xfrm>
-          <a:prstGeom prst="rect">
-            <a:avLst/>
-          </a:prstGeom>
-          <a:noFill/>
-        </p:spPr>
-        <p:txBody>
-          <a:bodyPr wrap="none">
-            <a:spAutoFit/>
-          </a:bodyPr>
-          <a:lstStyle/>
-          <a:p>
-            <a:r>
-              <a:rPr lang="en-US" sz="1000" dirty="0">
-                <a:solidFill>
-                  <a:srgbClr val="DD4444"/>
-                </a:solidFill>
-                <a:latin typeface="Calibri"/>
-              </a:rPr>
-              <a:t>18.06%</a:t>
-            </a:r>
-          </a:p>
-        </p:txBody>
-      </p:sp>
-      <p:sp>
-        <p:nvSpPr>
-          <p:cNvPr id="118" name="TextBox 117"/>
-          <p:cNvSpPr txBox="1"/>
-          <p:nvPr/>
-        </p:nvSpPr>
-        <p:spPr>
-          <a:xfrm>
-            <a:off x="3017520" y="1481328"/>
-            <a:ext cx="731520" cy="155448"/>
-          </a:xfrm>
-          <a:prstGeom prst="rect">
-            <a:avLst/>
-          </a:prstGeom>
-          <a:noFill/>
-        </p:spPr>
-        <p:txBody>
-          <a:bodyPr wrap="none">
-            <a:spAutoFit/>
-          </a:bodyPr>
-          <a:lstStyle/>
-          <a:p>
-            <a:r>
-              <a:rPr lang="en-US" sz="1000" dirty="0">
-                <a:solidFill>
-                  <a:srgbClr val="DD4444"/>
-                </a:solidFill>
-                <a:latin typeface="Calibri"/>
-              </a:rPr>
-              <a:t>132,972</a:t>
-            </a:r>
-          </a:p>
-        </p:txBody>
-      </p:sp>
-      <p:sp>
-        <p:nvSpPr>
-          <p:cNvPr id="119" name="TextBox 118"/>
-          <p:cNvSpPr txBox="1"/>
-          <p:nvPr/>
-        </p:nvSpPr>
-        <p:spPr>
-          <a:xfrm>
-            <a:off x="3794760" y="1481328"/>
-            <a:ext cx="502920" cy="155448"/>
-          </a:xfrm>
-          <a:prstGeom prst="rect">
-            <a:avLst/>
-          </a:prstGeom>
-          <a:noFill/>
-        </p:spPr>
-        <p:txBody>
-          <a:bodyPr wrap="none">
-            <a:spAutoFit/>
-          </a:bodyPr>
-          <a:lstStyle/>
-          <a:p>
-            <a:r>
-              <a:rPr lang="en-US" sz="1000" dirty="0">
-                <a:solidFill>
-                  <a:srgbClr val="DD4444"/>
-                </a:solidFill>
-                <a:latin typeface="Calibri"/>
-              </a:rPr>
-              <a:t>15.68%</a:t>
-            </a:r>
-          </a:p>
-        </p:txBody>
-      </p:sp>
-      <p:sp>
-        <p:nvSpPr>
-          <p:cNvPr id="120" name="TextBox 119"/>
-          <p:cNvSpPr txBox="1"/>
-          <p:nvPr/>
-        </p:nvSpPr>
-        <p:spPr>
-          <a:xfrm>
-            <a:off x="4343400" y="1481328"/>
-            <a:ext cx="594360" cy="155448"/>
-          </a:xfrm>
-          <a:prstGeom prst="rect">
-            <a:avLst/>
-          </a:prstGeom>
-          <a:noFill/>
-        </p:spPr>
-        <p:txBody>
-          <a:bodyPr wrap="none">
-            <a:spAutoFit/>
-          </a:bodyPr>
-          <a:lstStyle/>
-          <a:p>
-            <a:r>
-              <a:rPr lang="en-US" sz="1000" dirty="0">
-                <a:solidFill>
-                  <a:srgbClr val="DD4444"/>
-                </a:solidFill>
-                <a:latin typeface="Calibri"/>
-              </a:rPr>
-              <a:t>-24,581</a:t>
-            </a:r>
-          </a:p>
-        </p:txBody>
-      </p:sp>
-      <p:sp>
-        <p:nvSpPr>
-          <p:cNvPr id="121" name="TextBox 120"/>
-          <p:cNvSpPr txBox="1"/>
-          <p:nvPr/>
-        </p:nvSpPr>
-        <p:spPr>
-          <a:xfrm>
-            <a:off x="256032" y="1645920"/>
-            <a:ext cx="1188720" cy="155448"/>
-          </a:xfrm>
-          <a:prstGeom prst="rect">
-            <a:avLst/>
-          </a:prstGeom>
-          <a:noFill/>
-        </p:spPr>
-        <p:txBody>
-          <a:bodyPr wrap="none">
-            <a:spAutoFit/>
-          </a:bodyPr>
-          <a:lstStyle/>
-          <a:p>
-            <a:r>
-              <a:rPr lang="en-US" sz="1000" dirty="0">
-                <a:solidFill>
-                  <a:srgbClr val="DD4444"/>
-                </a:solidFill>
-                <a:latin typeface="Calibri"/>
-              </a:rPr>
-              <a:t>Conger</a:t>
-            </a:r>
-          </a:p>
-        </p:txBody>
-      </p:sp>
-      <p:sp>
-        <p:nvSpPr>
-          <p:cNvPr id="122" name="TextBox 121"/>
-          <p:cNvSpPr txBox="1"/>
-          <p:nvPr/>
-        </p:nvSpPr>
-        <p:spPr>
-          <a:xfrm>
-            <a:off x="1508760" y="1645920"/>
-            <a:ext cx="822960" cy="155448"/>
-          </a:xfrm>
-          <a:prstGeom prst="rect">
-            <a:avLst/>
-          </a:prstGeom>
-          <a:noFill/>
-        </p:spPr>
-        <p:txBody>
-          <a:bodyPr wrap="none">
-            <a:spAutoFit/>
-          </a:bodyPr>
-          <a:lstStyle/>
-          <a:p>
-            <a:r>
-              <a:rPr lang="en-US" sz="1000" dirty="0">
-                <a:solidFill>
-                  <a:srgbClr val="DD4444"/>
-                </a:solidFill>
-                <a:latin typeface="Calibri"/>
-              </a:rPr>
-              <a:t>73,000</a:t>
-            </a:r>
-          </a:p>
-        </p:txBody>
-      </p:sp>
-      <p:sp>
-        <p:nvSpPr>
-          <p:cNvPr id="123" name="TextBox 122"/>
-          <p:cNvSpPr txBox="1"/>
-          <p:nvPr/>
-        </p:nvSpPr>
-        <p:spPr>
-          <a:xfrm>
-            <a:off x="2377440" y="1645920"/>
-            <a:ext cx="594360" cy="155448"/>
-          </a:xfrm>
-          <a:prstGeom prst="rect">
-            <a:avLst/>
-          </a:prstGeom>
-          <a:noFill/>
-        </p:spPr>
-        <p:txBody>
-          <a:bodyPr wrap="none">
-            <a:spAutoFit/>
-          </a:bodyPr>
-          <a:lstStyle/>
-          <a:p>
-            <a:r>
-              <a:rPr lang="en-US" sz="1000" dirty="0">
-                <a:solidFill>
-                  <a:srgbClr val="DD4444"/>
-                </a:solidFill>
-                <a:latin typeface="Calibri"/>
-              </a:rPr>
-              <a:t> 8.37%</a:t>
-            </a:r>
-          </a:p>
-        </p:txBody>
-      </p:sp>
-      <p:sp>
-        <p:nvSpPr>
-          <p:cNvPr id="124" name="TextBox 123"/>
-          <p:cNvSpPr txBox="1"/>
-          <p:nvPr/>
-        </p:nvSpPr>
-        <p:spPr>
-          <a:xfrm>
-            <a:off x="3017520" y="1645920"/>
-            <a:ext cx="731520" cy="155448"/>
-          </a:xfrm>
-          <a:prstGeom prst="rect">
-            <a:avLst/>
-          </a:prstGeom>
-          <a:noFill/>
-        </p:spPr>
-        <p:txBody>
-          <a:bodyPr wrap="none">
-            <a:spAutoFit/>
-          </a:bodyPr>
-          <a:lstStyle/>
-          <a:p>
-            <a:r>
-              <a:rPr lang="en-US" sz="1000" dirty="0">
-                <a:solidFill>
-                  <a:srgbClr val="DD4444"/>
-                </a:solidFill>
-                <a:latin typeface="Calibri"/>
-              </a:rPr>
-              <a:t>29,000</a:t>
-            </a:r>
-          </a:p>
-        </p:txBody>
-      </p:sp>
-      <p:sp>
-        <p:nvSpPr>
-          <p:cNvPr id="125" name="TextBox 124"/>
-          <p:cNvSpPr txBox="1"/>
-          <p:nvPr/>
-        </p:nvSpPr>
-        <p:spPr>
-          <a:xfrm>
-            <a:off x="3794760" y="1645920"/>
-            <a:ext cx="502920" cy="155448"/>
-          </a:xfrm>
-          <a:prstGeom prst="rect">
-            <a:avLst/>
-          </a:prstGeom>
-          <a:noFill/>
-        </p:spPr>
-        <p:txBody>
-          <a:bodyPr wrap="none">
-            <a:spAutoFit/>
-          </a:bodyPr>
-          <a:lstStyle/>
-          <a:p>
-            <a:r>
-              <a:rPr lang="en-US" sz="1000" dirty="0">
-                <a:solidFill>
-                  <a:srgbClr val="DD4444"/>
-                </a:solidFill>
-                <a:latin typeface="Calibri"/>
-              </a:rPr>
-              <a:t> 3.42%</a:t>
-            </a:r>
-          </a:p>
-        </p:txBody>
-      </p:sp>
-      <p:sp>
-        <p:nvSpPr>
-          <p:cNvPr id="126" name="TextBox 125"/>
-          <p:cNvSpPr txBox="1"/>
-          <p:nvPr/>
-        </p:nvSpPr>
-        <p:spPr>
-          <a:xfrm>
-            <a:off x="4343400" y="1645920"/>
-            <a:ext cx="594360" cy="155448"/>
-          </a:xfrm>
-          <a:prstGeom prst="rect">
-            <a:avLst/>
-          </a:prstGeom>
-          <a:noFill/>
-        </p:spPr>
-        <p:txBody>
-          <a:bodyPr wrap="none">
-            <a:spAutoFit/>
-          </a:bodyPr>
-          <a:lstStyle/>
-          <a:p>
-            <a:r>
-              <a:rPr lang="en-US" sz="1000" dirty="0">
-                <a:solidFill>
-                  <a:srgbClr val="DD4444"/>
-                </a:solidFill>
-                <a:latin typeface="Calibri"/>
-              </a:rPr>
-              <a:t>-44,000</a:t>
-            </a:r>
-          </a:p>
-        </p:txBody>
-      </p:sp>
-      <p:sp>
-        <p:nvSpPr>
-          <p:cNvPr id="127" name="TextBox 126"/>
-          <p:cNvSpPr txBox="1"/>
-          <p:nvPr/>
-        </p:nvSpPr>
-        <p:spPr>
-          <a:xfrm>
-            <a:off x="256032" y="1810512"/>
-            <a:ext cx="1188720" cy="155448"/>
-          </a:xfrm>
-          <a:prstGeom prst="rect">
-            <a:avLst/>
-          </a:prstGeom>
-          <a:noFill/>
-        </p:spPr>
-        <p:txBody>
-          <a:bodyPr wrap="none">
-            <a:spAutoFit/>
-          </a:bodyPr>
-          <a:lstStyle/>
-          <a:p>
-            <a:r>
-              <a:rPr lang="en-US" sz="1000" dirty="0">
-                <a:solidFill>
-                  <a:srgbClr val="CCCCCC"/>
-                </a:solidFill>
-                <a:latin typeface="Calibri"/>
-              </a:rPr>
-              <a:t>Rufer</a:t>
-            </a:r>
-          </a:p>
-        </p:txBody>
-      </p:sp>
-      <p:sp>
-        <p:nvSpPr>
-          <p:cNvPr id="128" name="TextBox 127"/>
-          <p:cNvSpPr txBox="1"/>
-          <p:nvPr/>
-        </p:nvSpPr>
-        <p:spPr>
-          <a:xfrm>
-            <a:off x="1508760" y="1810512"/>
-            <a:ext cx="822960" cy="155448"/>
-          </a:xfrm>
-          <a:prstGeom prst="rect">
-            <a:avLst/>
-          </a:prstGeom>
-          <a:noFill/>
-        </p:spPr>
-        <p:txBody>
-          <a:bodyPr wrap="none">
-            <a:spAutoFit/>
-          </a:bodyPr>
-          <a:lstStyle/>
-          <a:p>
-            <a:r>
-              <a:rPr lang="en-US" sz="1000" dirty="0">
-                <a:solidFill>
-                  <a:srgbClr val="CCCCCC"/>
-                </a:solidFill>
-                <a:latin typeface="Calibri"/>
-              </a:rPr>
-              <a:t>91,000</a:t>
-            </a:r>
-          </a:p>
-        </p:txBody>
-      </p:sp>
-      <p:sp>
-        <p:nvSpPr>
-          <p:cNvPr id="129" name="TextBox 128"/>
-          <p:cNvSpPr txBox="1"/>
-          <p:nvPr/>
-        </p:nvSpPr>
-        <p:spPr>
-          <a:xfrm>
-            <a:off x="2377440" y="1810512"/>
-            <a:ext cx="594360" cy="155448"/>
-          </a:xfrm>
-          <a:prstGeom prst="rect">
-            <a:avLst/>
-          </a:prstGeom>
-          <a:noFill/>
-        </p:spPr>
-        <p:txBody>
-          <a:bodyPr wrap="none">
-            <a:spAutoFit/>
-          </a:bodyPr>
-          <a:lstStyle/>
-          <a:p>
-            <a:r>
-              <a:rPr lang="en-US" sz="1000" dirty="0">
-                <a:solidFill>
-                  <a:srgbClr val="CCCCCC"/>
-                </a:solidFill>
-                <a:latin typeface="Calibri"/>
-              </a:rPr>
-              <a:t>10.43%</a:t>
-            </a:r>
-          </a:p>
-        </p:txBody>
-      </p:sp>
-      <p:sp>
-        <p:nvSpPr>
-          <p:cNvPr id="130" name="TextBox 129"/>
-          <p:cNvSpPr txBox="1"/>
-          <p:nvPr/>
-        </p:nvSpPr>
-        <p:spPr>
-          <a:xfrm>
-            <a:off x="3017520" y="1810512"/>
-            <a:ext cx="731520" cy="155448"/>
-          </a:xfrm>
-          <a:prstGeom prst="rect">
-            <a:avLst/>
-          </a:prstGeom>
-          <a:noFill/>
-        </p:spPr>
-        <p:txBody>
-          <a:bodyPr wrap="none">
-            <a:spAutoFit/>
-          </a:bodyPr>
-          <a:lstStyle/>
-          <a:p>
-            <a:r>
-              <a:rPr lang="en-US" sz="1000" dirty="0">
-                <a:solidFill>
-                  <a:srgbClr val="CCCCCC"/>
-                </a:solidFill>
-                <a:latin typeface="Calibri"/>
-              </a:rPr>
-              <a:t>—</a:t>
-            </a:r>
-          </a:p>
-        </p:txBody>
-      </p:sp>
-      <p:sp>
-        <p:nvSpPr>
-          <p:cNvPr id="131" name="TextBox 130"/>
-          <p:cNvSpPr txBox="1"/>
-          <p:nvPr/>
-        </p:nvSpPr>
-        <p:spPr>
-          <a:xfrm>
-            <a:off x="3794760" y="1810512"/>
-            <a:ext cx="502920" cy="155448"/>
-          </a:xfrm>
-          <a:prstGeom prst="rect">
-            <a:avLst/>
-          </a:prstGeom>
-          <a:noFill/>
-        </p:spPr>
-        <p:txBody>
-          <a:bodyPr wrap="none">
-            <a:spAutoFit/>
-          </a:bodyPr>
-          <a:lstStyle/>
-          <a:p>
-            <a:r>
-              <a:rPr lang="en-US" sz="1000" dirty="0">
-                <a:solidFill>
-                  <a:srgbClr val="CCCCCC"/>
-                </a:solidFill>
-                <a:latin typeface="Calibri"/>
-              </a:rPr>
-              <a:t>—</a:t>
-            </a:r>
-          </a:p>
-        </p:txBody>
-      </p:sp>
-      <p:sp>
-        <p:nvSpPr>
-          <p:cNvPr id="132" name="TextBox 131"/>
-          <p:cNvSpPr txBox="1"/>
-          <p:nvPr/>
-        </p:nvSpPr>
-        <p:spPr>
-          <a:xfrm>
-            <a:off x="4343400" y="1810512"/>
-            <a:ext cx="594360" cy="155448"/>
-          </a:xfrm>
-          <a:prstGeom prst="rect">
-            <a:avLst/>
-          </a:prstGeom>
-          <a:noFill/>
-        </p:spPr>
-        <p:txBody>
-          <a:bodyPr wrap="none">
-            <a:spAutoFit/>
-          </a:bodyPr>
-          <a:lstStyle/>
-          <a:p>
-            <a:r>
-              <a:rPr lang="en-US" sz="1000" dirty="0">
-                <a:solidFill>
-                  <a:srgbClr val="CCCCCC"/>
-                </a:solidFill>
-                <a:latin typeface="Calibri"/>
-              </a:rPr>
-              <a:t>—</a:t>
-            </a:r>
-          </a:p>
-        </p:txBody>
-      </p:sp>
-      <p:sp>
-        <p:nvSpPr>
-          <p:cNvPr id="133" name="TextBox 132"/>
-          <p:cNvSpPr txBox="1"/>
-          <p:nvPr/>
-        </p:nvSpPr>
-        <p:spPr>
-          <a:xfrm>
-            <a:off x="256032" y="1975104"/>
-            <a:ext cx="1188720" cy="155448"/>
-          </a:xfrm>
-          <a:prstGeom prst="rect">
-            <a:avLst/>
-          </a:prstGeom>
-          <a:noFill/>
-        </p:spPr>
-        <p:txBody>
-          <a:bodyPr wrap="none">
-            <a:spAutoFit/>
-          </a:bodyPr>
-          <a:lstStyle/>
-          <a:p>
-            <a:r>
-              <a:rPr lang="en-US" sz="1000" dirty="0">
-                <a:solidFill>
-                  <a:srgbClr val="CCCCCC"/>
-                </a:solidFill>
-                <a:latin typeface="Calibri"/>
-              </a:rPr>
-              <a:t>Other</a:t>
-            </a:r>
-          </a:p>
-        </p:txBody>
-      </p:sp>
-      <p:sp>
-        <p:nvSpPr>
-          <p:cNvPr id="134" name="TextBox 133"/>
-          <p:cNvSpPr txBox="1"/>
-          <p:nvPr/>
-        </p:nvSpPr>
-        <p:spPr>
-          <a:xfrm>
-            <a:off x="1508760" y="1975104"/>
-            <a:ext cx="822960" cy="155448"/>
-          </a:xfrm>
-          <a:prstGeom prst="rect">
-            <a:avLst/>
-          </a:prstGeom>
-          <a:noFill/>
-        </p:spPr>
-        <p:txBody>
-          <a:bodyPr wrap="none">
-            <a:spAutoFit/>
-          </a:bodyPr>
-          <a:lstStyle/>
-          <a:p>
-            <a:r>
-              <a:rPr lang="en-US" sz="1000" dirty="0">
-                <a:solidFill>
-                  <a:srgbClr val="CCCCCC"/>
-                </a:solidFill>
-                <a:latin typeface="Calibri"/>
-              </a:rPr>
-              <a:t>167,972</a:t>
-            </a:r>
-          </a:p>
-        </p:txBody>
-      </p:sp>
-      <p:sp>
-        <p:nvSpPr>
-          <p:cNvPr id="135" name="TextBox 134"/>
-          <p:cNvSpPr txBox="1"/>
-          <p:nvPr/>
-        </p:nvSpPr>
-        <p:spPr>
-          <a:xfrm>
-            <a:off x="2377440" y="1975104"/>
-            <a:ext cx="594360" cy="155448"/>
-          </a:xfrm>
-          <a:prstGeom prst="rect">
-            <a:avLst/>
-          </a:prstGeom>
-          <a:noFill/>
-        </p:spPr>
-        <p:txBody>
-          <a:bodyPr wrap="none">
-            <a:spAutoFit/>
-          </a:bodyPr>
-          <a:lstStyle/>
-          <a:p>
-            <a:r>
-              <a:rPr lang="en-US" sz="1000" dirty="0">
-                <a:solidFill>
-                  <a:srgbClr val="CCCCCC"/>
-                </a:solidFill>
-                <a:latin typeface="Calibri"/>
-              </a:rPr>
-              <a:t>19.25%</a:t>
-            </a:r>
-          </a:p>
-        </p:txBody>
-      </p:sp>
-      <p:sp>
-        <p:nvSpPr>
-          <p:cNvPr id="136" name="TextBox 135"/>
-          <p:cNvSpPr txBox="1"/>
-          <p:nvPr/>
-        </p:nvSpPr>
-        <p:spPr>
-          <a:xfrm>
-            <a:off x="3017520" y="1975104"/>
-            <a:ext cx="731520" cy="155448"/>
-          </a:xfrm>
-          <a:prstGeom prst="rect">
-            <a:avLst/>
-          </a:prstGeom>
-          <a:noFill/>
-        </p:spPr>
-        <p:txBody>
-          <a:bodyPr wrap="none">
-            <a:spAutoFit/>
-          </a:bodyPr>
-          <a:lstStyle/>
-          <a:p>
-            <a:r>
-              <a:rPr lang="en-US" sz="1000" dirty="0">
-                <a:solidFill>
-                  <a:srgbClr val="CCCCCC"/>
-                </a:solidFill>
-                <a:latin typeface="Calibri"/>
-              </a:rPr>
-              <a:t>—</a:t>
-            </a:r>
-          </a:p>
-        </p:txBody>
-      </p:sp>
-      <p:sp>
-        <p:nvSpPr>
-          <p:cNvPr id="137" name="TextBox 136"/>
-          <p:cNvSpPr txBox="1"/>
-          <p:nvPr/>
-        </p:nvSpPr>
-        <p:spPr>
-          <a:xfrm>
-            <a:off x="3794760" y="1975104"/>
-            <a:ext cx="502920" cy="155448"/>
-          </a:xfrm>
-          <a:prstGeom prst="rect">
-            <a:avLst/>
-          </a:prstGeom>
-          <a:noFill/>
-        </p:spPr>
-        <p:txBody>
-          <a:bodyPr wrap="none">
-            <a:spAutoFit/>
-          </a:bodyPr>
-          <a:lstStyle/>
-          <a:p>
-            <a:r>
-              <a:rPr lang="en-US" sz="1000" dirty="0">
-                <a:solidFill>
-                  <a:srgbClr val="CCCCCC"/>
-                </a:solidFill>
-                <a:latin typeface="Calibri"/>
-              </a:rPr>
-              <a:t>—</a:t>
-            </a:r>
-          </a:p>
-        </p:txBody>
-      </p:sp>
-      <p:sp>
-        <p:nvSpPr>
-          <p:cNvPr id="138" name="TextBox 137"/>
-          <p:cNvSpPr txBox="1"/>
-          <p:nvPr/>
-        </p:nvSpPr>
-        <p:spPr>
-          <a:xfrm>
-            <a:off x="4343400" y="1975104"/>
-            <a:ext cx="594360" cy="155448"/>
-          </a:xfrm>
-          <a:prstGeom prst="rect">
-            <a:avLst/>
-          </a:prstGeom>
-          <a:noFill/>
-        </p:spPr>
-        <p:txBody>
-          <a:bodyPr wrap="none">
-            <a:spAutoFit/>
-          </a:bodyPr>
-          <a:lstStyle/>
-          <a:p>
-            <a:r>
-              <a:rPr lang="en-US" sz="1000" dirty="0">
-                <a:solidFill>
-                  <a:srgbClr val="CCCCCC"/>
-                </a:solidFill>
-                <a:latin typeface="Calibri"/>
-              </a:rPr>
-              <a:t>—</a:t>
-            </a:r>
-          </a:p>
-        </p:txBody>
-      </p:sp>
-      <p:sp>
-        <p:nvSpPr>
-          <p:cNvPr id="139" name="TextBox 138"/>
-          <p:cNvSpPr txBox="1"/>
-          <p:nvPr/>
-        </p:nvSpPr>
-        <p:spPr>
-          <a:xfrm>
-            <a:off x="256032" y="2176272"/>
-            <a:ext cx="1188720" cy="155448"/>
-          </a:xfrm>
-          <a:prstGeom prst="rect">
-            <a:avLst/>
-          </a:prstGeom>
-          <a:noFill/>
-        </p:spPr>
-        <p:txBody>
-          <a:bodyPr wrap="none">
-            <a:spAutoFit/>
-          </a:bodyPr>
-          <a:lstStyle/>
-          <a:p>
-            <a:r>
-              <a:rPr lang="en-US" sz="1000" b="1" dirty="0">
-                <a:solidFill>
-                  <a:srgbClr val="FFFFFF"/>
-                </a:solidFill>
-                <a:latin typeface="Calibri"/>
-              </a:rPr>
-              <a:t>TOTAL</a:t>
-            </a:r>
-          </a:p>
-        </p:txBody>
-      </p:sp>
-      <p:sp>
-        <p:nvSpPr>
-          <p:cNvPr id="140" name="TextBox 139"/>
-          <p:cNvSpPr txBox="1"/>
-          <p:nvPr/>
-        </p:nvSpPr>
-        <p:spPr>
-          <a:xfrm>
-            <a:off x="1508760" y="2176272"/>
-            <a:ext cx="822960" cy="155448"/>
-          </a:xfrm>
-          <a:prstGeom prst="rect">
-            <a:avLst/>
-          </a:prstGeom>
-          <a:noFill/>
-        </p:spPr>
-        <p:txBody>
-          <a:bodyPr wrap="none">
-            <a:spAutoFit/>
-          </a:bodyPr>
-          <a:lstStyle/>
-          <a:p>
-            <a:r>
-              <a:rPr lang="en-US" sz="1000" b="1" dirty="0">
-                <a:solidFill>
-                  <a:srgbClr val="FFFFFF"/>
-                </a:solidFill>
-                <a:latin typeface="Calibri"/>
-              </a:rPr>
-              <a:t>872,525</a:t>
-            </a:r>
-          </a:p>
-        </p:txBody>
-      </p:sp>
-      <p:sp>
-        <p:nvSpPr>
-          <p:cNvPr id="141" name="TextBox 140"/>
-          <p:cNvSpPr txBox="1"/>
-          <p:nvPr/>
-        </p:nvSpPr>
-        <p:spPr>
-          <a:xfrm>
-            <a:off x="2377440" y="2176272"/>
-            <a:ext cx="594360" cy="155448"/>
-          </a:xfrm>
-          <a:prstGeom prst="rect">
-            <a:avLst/>
-          </a:prstGeom>
-          <a:noFill/>
-        </p:spPr>
-        <p:txBody>
-          <a:bodyPr wrap="none">
-            <a:spAutoFit/>
-          </a:bodyPr>
-          <a:lstStyle/>
-          <a:p>
-            <a:r>
-              <a:rPr lang="en-US" sz="1000" b="1" dirty="0">
-                <a:solidFill>
-                  <a:srgbClr val="FFFFFF"/>
-                </a:solidFill>
-                <a:latin typeface="Calibri"/>
-              </a:rPr>
-              <a:t>100.0%</a:t>
-            </a:r>
-          </a:p>
-        </p:txBody>
-      </p:sp>
-      <p:sp>
-        <p:nvSpPr>
-          <p:cNvPr id="142" name="TextBox 141"/>
-          <p:cNvSpPr txBox="1"/>
-          <p:nvPr/>
-        </p:nvSpPr>
-        <p:spPr>
-          <a:xfrm>
-            <a:off x="3017520" y="2176272"/>
-            <a:ext cx="731520" cy="155448"/>
-          </a:xfrm>
-          <a:prstGeom prst="rect">
-            <a:avLst/>
-          </a:prstGeom>
-          <a:noFill/>
-        </p:spPr>
-        <p:txBody>
-          <a:bodyPr wrap="none">
-            <a:spAutoFit/>
-          </a:bodyPr>
-          <a:lstStyle/>
-          <a:p>
-            <a:r>
-              <a:rPr lang="en-US" sz="1000" b="1" dirty="0">
-                <a:solidFill>
-                  <a:srgbClr val="FFFFFF"/>
-                </a:solidFill>
-                <a:latin typeface="Calibri"/>
-              </a:rPr>
-              <a:t>847,944</a:t>
-            </a:r>
-          </a:p>
-        </p:txBody>
-      </p:sp>
-      <p:sp>
-        <p:nvSpPr>
-          <p:cNvPr id="143" name="TextBox 142"/>
-          <p:cNvSpPr txBox="1"/>
-          <p:nvPr/>
-        </p:nvSpPr>
-        <p:spPr>
-          <a:xfrm>
-            <a:off x="3794760" y="2176272"/>
-            <a:ext cx="502920" cy="155448"/>
-          </a:xfrm>
-          <a:prstGeom prst="rect">
-            <a:avLst/>
-          </a:prstGeom>
-          <a:noFill/>
-        </p:spPr>
-        <p:txBody>
-          <a:bodyPr wrap="none">
-            <a:spAutoFit/>
-          </a:bodyPr>
-          <a:lstStyle/>
-          <a:p>
-            <a:r>
-              <a:rPr lang="en-US" sz="1000" b="1" dirty="0">
-                <a:solidFill>
-                  <a:srgbClr val="FFFFFF"/>
-                </a:solidFill>
-                <a:latin typeface="Calibri"/>
-              </a:rPr>
-              <a:t>97.2%</a:t>
-            </a:r>
-          </a:p>
-        </p:txBody>
-      </p:sp>
-      <p:sp>
-        <p:nvSpPr>
-          <p:cNvPr id="144" name="TextBox 143"/>
-          <p:cNvSpPr txBox="1"/>
-          <p:nvPr/>
-        </p:nvSpPr>
-        <p:spPr>
-          <a:xfrm>
-            <a:off x="4343400" y="2176272"/>
-            <a:ext cx="594360" cy="155448"/>
-          </a:xfrm>
-          <a:prstGeom prst="rect">
-            <a:avLst/>
-          </a:prstGeom>
-          <a:noFill/>
-        </p:spPr>
-        <p:txBody>
-          <a:bodyPr wrap="none">
-            <a:spAutoFit/>
-          </a:bodyPr>
-          <a:lstStyle/>
-          <a:p>
+            <a:pPr algn="r"/>
             <a:r>
               <a:rPr lang="en-US" sz="1000" b="1" dirty="0">
                 <a:solidFill>
@@ -26917,7 +27058,7 @@
                 </a:solidFill>
                 <a:latin typeface="Calibri"/>
               </a:rPr>
-              <a:t>Increases the payout to Microcosm Astronautics Books (MTB Capital Inc.)</a:t>
+              <a:t>Increases the payout to Microcosm Astronautics Books</a:t>
             </a:r>
           </a:p>
         </p:txBody>
@@ -27633,8 +27774,8 @@
         </p:nvSpPr>
         <p:spPr>
           <a:xfrm>
-            <a:off x="4736592" y="3145536"/>
-            <a:ext cx="4160520" cy="365760"/>
+            <a:off x="4736592" y="3090672"/>
+            <a:ext cx="4160520" cy="411480"/>
           </a:xfrm>
           <a:prstGeom prst="rect">
             <a:avLst/>
@@ -27655,7 +27796,7 @@
                 </a:solidFill>
                 <a:latin typeface="Calibri"/>
               </a:rPr>
-              <a:t>Together these create the appearance of self-dealing, which a buyer, fairness-opinion provider or court would question.</a:t>
+              <a:t>Together: the appearance of self-dealing. Found by MTB Capital; these issues have held up Exos's independent Eqvista fairness opinion.</a:t>
             </a:r>
           </a:p>
         </p:txBody>
@@ -27813,7 +27954,7 @@
                 </a:solidFill>
                 <a:latin typeface="Calibri"/>
               </a:rPr>
-              <a:t>Every $1 paid to Microcosm/Wertz at close, $0.46 comes from holders outside that group. Holders outside the Microcosm/Wertz group own 46% of that pool and bear 46% of every uncorrected entry.</a:t>
+              <a:t>Of every $1 paid to Microcosm/Wertz at close, 46¢ comes from holders outside that group (they own 46% of the non-Exos pool).</a:t>
             </a:r>
           </a:p>
         </p:txBody>
@@ -27992,13 +28133,13 @@
           <a:p>
             <a:pPr algn="l"/>
             <a:r>
-              <a:rPr sz="1100" b="1" i="0">
+              <a:rPr sz="1000" b="1" i="0">
                 <a:solidFill>
                   <a:srgbClr val="FFCC44"/>
                 </a:solidFill>
                 <a:latin typeface="Calibri"/>
               </a:rPr>
-              <a:t>Microcosm can resolve this before the vote by providing the invoices and agreeing to the corrections. Motion 5 is decided by the disinterested directors (Quinn, Rufer, Conger).</a:t>
+              <a:t>Microcosm can resolve this before the vote by providing invoices and agreeing to the corrections. Motion 5 is decided by Quinn, Rufer and Conger.</a:t>
             </a:r>
           </a:p>
         </p:txBody>
@@ -29742,7 +29883,7 @@
         <p:spPr>
           <a:xfrm>
             <a:off x="256032" y="2624327"/>
-            <a:ext cx="8631936" cy="182880"/>
+            <a:ext cx="3931920" cy="182880"/>
           </a:xfrm>
           <a:prstGeom prst="rect">
             <a:avLst/>
@@ -29763,7 +29904,7 @@
                 </a:solidFill>
                 <a:latin typeface="Calibri"/>
               </a:rPr>
-              <a:t>IMPACT OF UNCORRECTED APRIL 30 ENTRIES  (negative to non-Wertz holders)</a:t>
+              <a:t>IF THE APRIL 30 ENTRIES ARE NOT CORRECTED</a:t>
             </a:r>
           </a:p>
         </p:txBody>
@@ -29776,8 +29917,8 @@
         </p:nvSpPr>
         <p:spPr>
           <a:xfrm>
-            <a:off x="256032" y="2834639"/>
-            <a:ext cx="4754880" cy="201168"/>
+            <a:off x="256032" y="2834640"/>
+            <a:ext cx="3840480" cy="201168"/>
           </a:xfrm>
           <a:prstGeom prst="rect">
             <a:avLst/>
@@ -29798,7 +29939,7 @@
                 </a:solidFill>
                 <a:latin typeface="Calibri"/>
               </a:rPr>
-              <a:t>Step 1  —  Facility credit + capitalized interest ($448K not credited):</a:t>
+              <a:t>Step 1: facility credit + interest ($448K)</a:t>
             </a:r>
           </a:p>
         </p:txBody>
@@ -29811,8 +29952,8 @@
         </p:nvSpPr>
         <p:spPr>
           <a:xfrm>
-            <a:off x="4370832" y="2857500"/>
-            <a:ext cx="1645920" cy="201168"/>
+            <a:off x="4206240" y="2834640"/>
+            <a:ext cx="1371600" cy="201168"/>
           </a:xfrm>
           <a:prstGeom prst="rect">
             <a:avLst/>
@@ -29833,7 +29974,7 @@
                 </a:solidFill>
                 <a:latin typeface="Calibri"/>
               </a:rPr>
-              <a:t>Per 1%: −$5.5K</a:t>
+              <a:t>−$5.5K</a:t>
             </a:r>
           </a:p>
         </p:txBody>
@@ -29868,7 +30009,7 @@
                 </a:solidFill>
                 <a:latin typeface="Calibri"/>
               </a:rPr>
-              <a:t>|</a:t>
+              <a:t/>
             </a:r>
           </a:p>
         </p:txBody>
@@ -29881,8 +30022,8 @@
         </p:nvSpPr>
         <p:spPr>
           <a:xfrm>
-            <a:off x="5669280" y="2812176"/>
-            <a:ext cx="1508760" cy="201168"/>
+            <a:off x="5669280" y="2834640"/>
+            <a:ext cx="1463040" cy="201168"/>
           </a:xfrm>
           <a:prstGeom prst="rect">
             <a:avLst/>
@@ -29903,7 +30044,7 @@
                 </a:solidFill>
                 <a:latin typeface="Calibri"/>
               </a:rPr>
-              <a:t>Conger: −$45.8K</a:t>
+              <a:t>−$45.8K</a:t>
             </a:r>
           </a:p>
         </p:txBody>
@@ -29916,8 +30057,8 @@
         </p:nvSpPr>
         <p:spPr>
           <a:xfrm>
-            <a:off x="256032" y="3090672"/>
-            <a:ext cx="4754880" cy="201168"/>
+            <a:off x="256032" y="3072384"/>
+            <a:ext cx="3840480" cy="201168"/>
           </a:xfrm>
           <a:prstGeom prst="rect">
             <a:avLst/>
@@ -29938,7 +30079,7 @@
                 </a:solidFill>
                 <a:latin typeface="Calibri"/>
               </a:rPr>
-              <a:t>Step 1+2  —  + Unsupported offsets if unresolved ($967K):</a:t>
+              <a:t>Steps 1+2: + unsupported offsets ($967K)</a:t>
             </a:r>
           </a:p>
         </p:txBody>
@@ -29951,8 +30092,8 @@
         </p:nvSpPr>
         <p:spPr>
           <a:xfrm>
-            <a:off x="4434839" y="3080051"/>
-            <a:ext cx="1645920" cy="201168"/>
+            <a:off x="4206240" y="3072384"/>
+            <a:ext cx="1371600" cy="201168"/>
           </a:xfrm>
           <a:prstGeom prst="rect">
             <a:avLst/>
@@ -29973,7 +30114,7 @@
                 </a:solidFill>
                 <a:latin typeface="Calibri"/>
               </a:rPr>
-              <a:t>Per 1%: −$11.8K</a:t>
+              <a:t>−$11.8K</a:t>
             </a:r>
           </a:p>
         </p:txBody>
@@ -30008,7 +30149,7 @@
                 </a:solidFill>
                 <a:latin typeface="Calibri"/>
               </a:rPr>
-              <a:t>|</a:t>
+              <a:t/>
             </a:r>
           </a:p>
         </p:txBody>
@@ -30021,8 +30162,8 @@
         </p:nvSpPr>
         <p:spPr>
           <a:xfrm>
-            <a:off x="5669280" y="3064514"/>
-            <a:ext cx="1508760" cy="246221"/>
+            <a:off x="5669280" y="3072384"/>
+            <a:ext cx="1463040" cy="201168"/>
           </a:xfrm>
           <a:prstGeom prst="rect">
             <a:avLst/>
@@ -30043,7 +30184,7 @@
                 </a:solidFill>
                 <a:latin typeface="Calibri"/>
               </a:rPr>
-              <a:t>Conger: −$</a:t>
+              <a:t>−$98.7K</a:t>
             </a:r>
             <a:r>
               <a:rPr lang="en-US" sz="1000" b="1" i="0" dirty="0">
@@ -30052,7 +30193,7 @@
                 </a:solidFill>
                 <a:latin typeface="Calibri"/>
               </a:rPr>
-              <a:t>98.7K  (Microcosm owes SSLC)</a:t>
+              <a:t/>
             </a:r>
             <a:endParaRPr sz="1000" b="1" i="0" dirty="0">
               <a:solidFill>
@@ -30374,7 +30515,7 @@
                 </a:solidFill>
                 <a:latin typeface="Calibri"/>
               </a:rPr>
-              <a:t>Book value today: −$1.44M equity (negative; standalone requires new capital to convert)</a:t>
+              <a:t>Today: book equity −$1.44M, so no cash to holders without a sale</a:t>
             </a:r>
           </a:p>
         </p:txBody>
@@ -30444,7 +30585,7 @@
                 </a:solidFill>
                 <a:latin typeface="Calibri"/>
               </a:rPr>
-              <a:t>$5.1M FY27 target still requires doubling last 3mo</a:t>
+              <a:t>Future: SSLC alone must double revenue to $5.1M+, with no new capital</a:t>
             </a:r>
           </a:p>
         </p:txBody>
@@ -30514,7 +30655,7 @@
                 </a:solidFill>
                 <a:latin typeface="Calibri"/>
               </a:rPr>
-              <a:t>Insider balances ($864K as booked) paid first</a:t>
+              <a:t>Insider balances ($864K as booked) are paid first</a:t>
             </a:r>
           </a:p>
         </p:txBody>
@@ -30667,8 +30808,8 @@
         </p:nvSpPr>
         <p:spPr>
           <a:xfrm>
-            <a:off x="256032" y="3310128"/>
-            <a:ext cx="4754880" cy="201168"/>
+            <a:off x="256032" y="3291840"/>
+            <a:ext cx="3840480" cy="201168"/>
           </a:xfrm>
           <a:prstGeom prst="rect">
             <a:avLst/>
@@ -30688,7 +30829,7 @@
                 </a:solidFill>
                 <a:latin typeface="Calibri"/>
               </a:rPr>
-              <a:t>Step 3  —  If full $812K Microcosm loan undocumented ($1.26M total):</a:t>
+              <a:t>Steps 1–3: + full $812K loan ($1.26M)</a:t>
             </a:r>
           </a:p>
         </p:txBody>
@@ -30701,8 +30842,8 @@
         </p:nvSpPr>
         <p:spPr>
           <a:xfrm>
-            <a:off x="5074920" y="3310128"/>
-            <a:ext cx="1645920" cy="201168"/>
+            <a:off x="4206240" y="3291840"/>
+            <a:ext cx="1371600" cy="201168"/>
           </a:xfrm>
           <a:prstGeom prst="rect">
             <a:avLst/>
@@ -30715,6 +30856,7 @@
           </a:bodyPr>
           <a:lstStyle/>
           <a:p>
+            <a:pPr algn="r"/>
             <a:r>
               <a:rPr lang="en-US" sz="1000" b="1">
                 <a:solidFill>
@@ -30722,7 +30864,7 @@
                 </a:solidFill>
                 <a:latin typeface="Calibri"/>
               </a:rPr>
-              <a:t>Per 1%: −$15.4K</a:t>
+              <a:t>−$15.4K</a:t>
             </a:r>
           </a:p>
         </p:txBody>
@@ -30756,7 +30898,7 @@
                 </a:solidFill>
                 <a:latin typeface="Calibri"/>
               </a:rPr>
-              <a:t>|</a:t>
+              <a:t/>
             </a:r>
           </a:p>
         </p:txBody>
@@ -30769,8 +30911,8 @@
         </p:nvSpPr>
         <p:spPr>
           <a:xfrm>
-            <a:off x="5669280" y="3285609"/>
-            <a:ext cx="1508760" cy="201168"/>
+            <a:off x="5669280" y="3291840"/>
+            <a:ext cx="1463040" cy="201168"/>
           </a:xfrm>
           <a:prstGeom prst="rect">
             <a:avLst/>
@@ -30783,6 +30925,7 @@
           </a:bodyPr>
           <a:lstStyle/>
           <a:p>
+            <a:pPr algn="r"/>
             <a:r>
               <a:rPr lang="en-US" sz="1000" b="1" dirty="0">
                 <a:solidFill>
@@ -30790,7 +30933,7 @@
                 </a:solidFill>
                 <a:latin typeface="Calibri"/>
               </a:rPr>
-              <a:t>Conger: −$128.7K</a:t>
+              <a:t>−$128.7K</a:t>
             </a:r>
           </a:p>
         </p:txBody>
@@ -31258,8 +31401,8 @@
         </p:nvSpPr>
         <p:spPr>
           <a:xfrm>
-            <a:off x="4370832" y="2624328"/>
-            <a:ext cx="1554480" cy="182880"/>
+            <a:off x="4206240" y="2624328"/>
+            <a:ext cx="1371600" cy="182880"/>
           </a:xfrm>
           <a:prstGeom prst="rect">
             <a:avLst/>
@@ -31272,6 +31415,7 @@
           </a:bodyPr>
           <a:lstStyle/>
           <a:p>
+            <a:pPr algn="r"/>
             <a:r>
               <a:rPr lang="en-US" sz="1000" dirty="0" b="1">
                 <a:solidFill>
@@ -31293,7 +31437,7 @@
         <p:spPr>
           <a:xfrm>
             <a:off x="5669280" y="2624328"/>
-            <a:ext cx="1508760" cy="182880"/>
+            <a:ext cx="1463040" cy="182880"/>
           </a:xfrm>
           <a:prstGeom prst="rect">
             <a:avLst/>
@@ -31306,6 +31450,7 @@
           </a:bodyPr>
           <a:lstStyle/>
           <a:p>
+            <a:pPr algn="r"/>
             <a:r>
               <a:rPr lang="en-US" sz="1000" dirty="0" b="1">
                 <a:solidFill>
@@ -31313,7 +31458,7 @@
                 </a:solidFill>
                 <a:latin typeface="Calibri"/>
               </a:rPr>
-              <a:t>Conger lost (73K sh.)</a:t>
+              <a:t>Conger (73K sh.)</a:t>
             </a:r>
           </a:p>
         </p:txBody>
@@ -31326,8 +31471,8 @@
         </p:nvSpPr>
         <p:spPr>
           <a:xfrm>
-            <a:off x="7223760" y="2624328"/>
-            <a:ext cx="1737360" cy="182880"/>
+            <a:off x="7269480" y="2624328"/>
+            <a:ext cx="1600200" cy="182880"/>
           </a:xfrm>
           <a:prstGeom prst="rect">
             <a:avLst/>
@@ -31340,6 +31485,7 @@
           </a:bodyPr>
           <a:lstStyle/>
           <a:p>
+            <a:pPr algn="r"/>
             <a:r>
               <a:rPr lang="en-US" sz="1000" dirty="0" b="1">
                 <a:solidFill>
@@ -31347,7 +31493,7 @@
                 </a:solidFill>
                 <a:latin typeface="Calibri"/>
               </a:rPr>
-              <a:t>Rufer lost (91K sh.)</a:t>
+              <a:t>Rufer (91K sh.)</a:t>
             </a:r>
           </a:p>
         </p:txBody>
@@ -31360,8 +31506,8 @@
         </p:nvSpPr>
         <p:spPr>
           <a:xfrm>
-            <a:off x="7223760" y="2816352"/>
-            <a:ext cx="1737360" cy="201168"/>
+            <a:off x="7269480" y="2834640"/>
+            <a:ext cx="1600200" cy="201168"/>
           </a:xfrm>
           <a:prstGeom prst="rect">
             <a:avLst/>
@@ -31374,6 +31520,7 @@
           </a:bodyPr>
           <a:lstStyle/>
           <a:p>
+            <a:pPr algn="r"/>
             <a:r>
               <a:rPr lang="en-US" sz="1000" dirty="0">
                 <a:solidFill>
@@ -31381,7 +31528,7 @@
                 </a:solidFill>
                 <a:latin typeface="Calibri"/>
               </a:rPr>
-              <a:t>Rufer: −$57.1K</a:t>
+              <a:t>−$57.1K</a:t>
             </a:r>
           </a:p>
         </p:txBody>
@@ -31394,8 +31541,8 @@
         </p:nvSpPr>
         <p:spPr>
           <a:xfrm>
-            <a:off x="7223760" y="3063240"/>
-            <a:ext cx="1737360" cy="201168"/>
+            <a:off x="7269480" y="3072384"/>
+            <a:ext cx="1600200" cy="201168"/>
           </a:xfrm>
           <a:prstGeom prst="rect">
             <a:avLst/>
@@ -31408,6 +31555,7 @@
           </a:bodyPr>
           <a:lstStyle/>
           <a:p>
+            <a:pPr algn="r"/>
             <a:r>
               <a:rPr lang="en-US" sz="1000" dirty="0">
                 <a:solidFill>
@@ -31415,7 +31563,7 @@
                 </a:solidFill>
                 <a:latin typeface="Calibri"/>
               </a:rPr>
-              <a:t>Rufer: −$123.0K</a:t>
+              <a:t>−$123.0K</a:t>
             </a:r>
           </a:p>
         </p:txBody>
@@ -31428,8 +31576,8 @@
         </p:nvSpPr>
         <p:spPr>
           <a:xfrm>
-            <a:off x="7223760" y="3310128"/>
-            <a:ext cx="1737360" cy="201168"/>
+            <a:off x="7269480" y="3291840"/>
+            <a:ext cx="1600200" cy="201168"/>
           </a:xfrm>
           <a:prstGeom prst="rect">
             <a:avLst/>
@@ -31442,6 +31590,7 @@
           </a:bodyPr>
           <a:lstStyle/>
           <a:p>
+            <a:pPr algn="r"/>
             <a:r>
               <a:rPr lang="en-US" sz="1000" dirty="0">
                 <a:solidFill>
@@ -31449,7 +31598,7 @@
                 </a:solidFill>
                 <a:latin typeface="Calibri"/>
               </a:rPr>
-              <a:t>Rufer: −$160.5K</a:t>
+              <a:t>−$160.5K</a:t>
             </a:r>
           </a:p>
         </p:txBody>
@@ -31867,38 +32016,6 @@
       </p:sp>
       <p:sp>
         <p:nvSpPr>
-          <p:cNvPr id="13" name="Shape 11"/>
-          <p:cNvSpPr/>
-          <p:nvPr/>
-        </p:nvSpPr>
-        <p:spPr>
-          <a:xfrm>
-            <a:off x="914400" y="2267712"/>
-            <a:ext cx="5669280" cy="393192"/>
-          </a:xfrm>
-          <a:prstGeom prst="rect">
-            <a:avLst/>
-          </a:prstGeom>
-          <a:solidFill>
-            <a:srgbClr val="222222"/>
-          </a:solidFill>
-          <a:ln w="12700">
-            <a:solidFill>
-              <a:srgbClr val="333333"/>
-            </a:solidFill>
-            <a:prstDash val="solid"/>
-          </a:ln>
-        </p:spPr>
-        <p:txBody>
-          <a:bodyPr/>
-          <a:lstStyle/>
-          <a:p>
-            <a:endParaRPr/>
-          </a:p>
-        </p:txBody>
-      </p:sp>
-      <p:sp>
-        <p:nvSpPr>
           <p:cNvPr id="19" name="Shape 17"/>
           <p:cNvSpPr/>
           <p:nvPr/>
@@ -31959,7 +32076,7 @@
                   <a:srgbClr val="F26A21"/>
                 </a:solidFill>
               </a:rPr>
-              <a:t>① Cash at close — target by Jan 15th</a:t>
+              <a:t>① Cash at close — target Jan 15, 2027</a:t>
             </a:r>
             <a:endParaRPr lang="en-US" sz="1300" dirty="0"/>
           </a:p>

</xml_diff>

<commit_message>
SSLC r5: print (light) version + payout slide fee alignment/rule fix; print-version script
</commit_message>
<xml_diff>
--- a/drafts/Exos_SSLC_Board_Offer_Overview_2026-10-12_r5.pptx
+++ b/drafts/Exos_SSLC_Board_Offer_Overview_2026-10-12_r5.pptx
@@ -12208,7 +12208,7 @@
         </p:nvSpPr>
         <p:spPr>
           <a:xfrm>
-            <a:off x="274320" y="3082442"/>
+            <a:off x="274320" y="3049524"/>
             <a:ext cx="3154679" cy="169164"/>
           </a:xfrm>
           <a:prstGeom prst="rect">
@@ -12243,7 +12243,7 @@
         </p:nvSpPr>
         <p:spPr>
           <a:xfrm>
-            <a:off x="3474719" y="3082442"/>
+            <a:off x="3474719" y="3049524"/>
             <a:ext cx="914400" cy="169164"/>
           </a:xfrm>
           <a:prstGeom prst="rect">
@@ -12278,7 +12278,7 @@
         </p:nvSpPr>
         <p:spPr>
           <a:xfrm>
-            <a:off x="274320" y="3251606"/>
+            <a:off x="274320" y="3259836"/>
             <a:ext cx="4151376" cy="13716"/>
           </a:xfrm>
           <a:prstGeom prst="rect">
@@ -13820,7 +13820,7 @@
         </p:nvSpPr>
         <p:spPr>
           <a:xfrm>
-            <a:off x="3474720" y="2340864"/>
+            <a:off x="3474719" y="2340864"/>
             <a:ext cx="914400" cy="169164"/>
           </a:xfrm>
           <a:prstGeom prst="rect">
@@ -13834,6 +13834,7 @@
           </a:bodyPr>
           <a:lstStyle/>
           <a:p>
+            <a:pPr algn="r"/>
             <a:r>
               <a:rPr lang="en-US" sz="1000" dirty="0">
                 <a:solidFill>

</xml_diff>